<commit_message>
Add deck appendix (unit economics + channel-test scorecards); satellite desk-recon step
- biliran-gtm-plan.pptx: +2 appendix slides — the ₱99,500 unit economics
  (on-grid vs off-grid cost stack + gross margin, battery-tier margin
  warning) and the two pre-registered channel-test scorecards. 17 slides,
  validated clean.
- biliran-recon-toolkit.md: add Google Earth / satellite desk-recon step
  for spotting existing arrays, with its limits and a pointer to BILECO's
  net-metering list as the authoritative source.

Co-Authored-By: Claude Opus 4.8 <noreply@anthropic.com>
Claude-Session: https://claude.ai/code/session_015Q8pBqvoQZqzcJmfeCa9JG
</commit_message>
<xml_diff>
--- a/docs/biliran-gtm-plan.pptx
+++ b/docs/biliran-gtm-plan.pptx
@@ -20,9 +20,11 @@
     <p:sldId id="268" r:id="rId14"/>
     <p:sldId id="269" r:id="rId15"/>
     <p:sldId id="270" r:id="rId16"/>
+    <p:sldId id="271" r:id="rId17"/>
+    <p:sldId id="272" r:id="rId18"/>
   </p:sldIdLst>
   <p:notesMasterIdLst>
-    <p:notesMasterId r:id="rId17"/>
+    <p:notesMasterId r:id="rId19"/>
   </p:notesMasterIdLst>
   <p:sldSz cx="12192000" cy="6858000"/>
   <p:notesSz cx="6858000" cy="12192000"/>
@@ -1044,7 +1046,7 @@
           <a:p>
             <a:r>
               <a:rPr lang="en-US" dirty="0"/>
-              <a:t>The whole plan in one line. Sell now, build the moat later, on our own money.</a:t>
+              <a:t>The off-grid battery is the margin risk. We hold a disciplined base battery and upsell storage. Our own fabrication is where guaranteed margin comes from.</a:t>
             </a:r>
             <a:endParaRPr lang="en-US" dirty="0"/>
           </a:p>
@@ -1068,6 +1070,182 @@
             <a:fld id="{F7021451-1387-4CA6-816F-3879F97B5CBC}" type="slidenum">
               <a:rPr lang="en-US"/>
               <a:t>15</a:t>
+            </a:fld>
+            <a:endParaRPr lang="en-US"/>
+          </a:p>
+        </p:txBody>
+      </p:sp>
+    </p:spTree>
+    <p:extLst>
+      <p:ext uri="{BB962C8B-B14F-4D97-AF65-F5344CB8AC3E}">
+        <p14:creationId xmlns:p14="http://schemas.microsoft.com/office/powerpoint/2010/main" val="1024086991"/>
+      </p:ext>
+    </p:extLst>
+  </p:cSld>
+  <p:clrMapOvr>
+    <a:masterClrMapping/>
+  </p:clrMapOvr>
+</p:notes>
+</file>
+
+<file path=ppt/notesSlides/notesSlide16.xml><?xml version="1.0" encoding="utf-8"?>
+<p:notes xmlns:a="http://schemas.openxmlformats.org/drawingml/2006/main" xmlns:r="http://schemas.openxmlformats.org/officeDocument/2006/relationships" xmlns:p="http://schemas.openxmlformats.org/presentationml/2006/main">
+  <p:cSld>
+    <p:spTree>
+      <p:nvGrpSpPr>
+        <p:cNvPr id="1" name=""/>
+        <p:cNvGrpSpPr/>
+        <p:nvPr/>
+      </p:nvGrpSpPr>
+      <p:grpSpPr>
+        <a:xfrm>
+          <a:off x="0" y="0"/>
+          <a:ext cx="0" cy="0"/>
+          <a:chOff x="0" y="0"/>
+          <a:chExt cx="0" cy="0"/>
+        </a:xfrm>
+      </p:grpSpPr>
+      <p:sp>
+        <p:nvSpPr>
+          <p:cNvPr id="2" name="Slide Image Placeholder 1"/>
+          <p:cNvSpPr>
+            <a:spLocks noGrp="1" noRot="1" noChangeAspect="1"/>
+          </p:cNvSpPr>
+          <p:nvPr>
+            <p:ph type="sldImg"/>
+          </p:nvPr>
+        </p:nvSpPr>
+        <p:spPr/>
+      </p:sp>
+      <p:sp>
+        <p:nvSpPr>
+          <p:cNvPr id="3" name="Notes Placeholder 2"/>
+          <p:cNvSpPr>
+            <a:spLocks noGrp="1"/>
+          </p:cNvSpPr>
+          <p:nvPr>
+            <p:ph type="body" idx="1"/>
+          </p:nvPr>
+        </p:nvSpPr>
+        <p:spPr/>
+        <p:txBody>
+          <a:bodyPr/>
+          <a:lstStyle/>
+          <a:p>
+            <a:r>
+              <a:rPr lang="en-US" dirty="0"/>
+              <a:t>Every test has a number written down before launch. No number, no evidence. We only scale a channel that produces paid deposits.</a:t>
+            </a:r>
+            <a:endParaRPr lang="en-US" dirty="0"/>
+          </a:p>
+        </p:txBody>
+      </p:sp>
+      <p:sp>
+        <p:nvSpPr>
+          <p:cNvPr id="4" name="Slide Number Placeholder 3"/>
+          <p:cNvSpPr>
+            <a:spLocks noGrp="1"/>
+          </p:cNvSpPr>
+          <p:nvPr>
+            <p:ph type="sldNum" sz="quarter" idx="10"/>
+          </p:nvPr>
+        </p:nvSpPr>
+        <p:spPr/>
+        <p:txBody>
+          <a:bodyPr/>
+          <a:lstStyle/>
+          <a:p>
+            <a:fld id="{F7021451-1387-4CA6-816F-3879F97B5CBC}" type="slidenum">
+              <a:rPr lang="en-US"/>
+              <a:t>16</a:t>
+            </a:fld>
+            <a:endParaRPr lang="en-US"/>
+          </a:p>
+        </p:txBody>
+      </p:sp>
+    </p:spTree>
+    <p:extLst>
+      <p:ext uri="{BB962C8B-B14F-4D97-AF65-F5344CB8AC3E}">
+        <p14:creationId xmlns:p14="http://schemas.microsoft.com/office/powerpoint/2010/main" val="1024086991"/>
+      </p:ext>
+    </p:extLst>
+  </p:cSld>
+  <p:clrMapOvr>
+    <a:masterClrMapping/>
+  </p:clrMapOvr>
+</p:notes>
+</file>
+
+<file path=ppt/notesSlides/notesSlide17.xml><?xml version="1.0" encoding="utf-8"?>
+<p:notes xmlns:a="http://schemas.openxmlformats.org/drawingml/2006/main" xmlns:r="http://schemas.openxmlformats.org/officeDocument/2006/relationships" xmlns:p="http://schemas.openxmlformats.org/presentationml/2006/main">
+  <p:cSld>
+    <p:spTree>
+      <p:nvGrpSpPr>
+        <p:cNvPr id="1" name=""/>
+        <p:cNvGrpSpPr/>
+        <p:nvPr/>
+      </p:nvGrpSpPr>
+      <p:grpSpPr>
+        <a:xfrm>
+          <a:off x="0" y="0"/>
+          <a:ext cx="0" cy="0"/>
+          <a:chOff x="0" y="0"/>
+          <a:chExt cx="0" cy="0"/>
+        </a:xfrm>
+      </p:grpSpPr>
+      <p:sp>
+        <p:nvSpPr>
+          <p:cNvPr id="2" name="Slide Image Placeholder 1"/>
+          <p:cNvSpPr>
+            <a:spLocks noGrp="1" noRot="1" noChangeAspect="1"/>
+          </p:cNvSpPr>
+          <p:nvPr>
+            <p:ph type="sldImg"/>
+          </p:nvPr>
+        </p:nvSpPr>
+        <p:spPr/>
+      </p:sp>
+      <p:sp>
+        <p:nvSpPr>
+          <p:cNvPr id="3" name="Notes Placeholder 2"/>
+          <p:cNvSpPr>
+            <a:spLocks noGrp="1"/>
+          </p:cNvSpPr>
+          <p:nvPr>
+            <p:ph type="body" idx="1"/>
+          </p:nvPr>
+        </p:nvSpPr>
+        <p:spPr/>
+        <p:txBody>
+          <a:bodyPr/>
+          <a:lstStyle/>
+          <a:p>
+            <a:r>
+              <a:rPr lang="en-US" dirty="0"/>
+              <a:t>The whole plan in one line. Sell now, build the moat later, on our own money.</a:t>
+            </a:r>
+            <a:endParaRPr lang="en-US" dirty="0"/>
+          </a:p>
+        </p:txBody>
+      </p:sp>
+      <p:sp>
+        <p:nvSpPr>
+          <p:cNvPr id="4" name="Slide Number Placeholder 3"/>
+          <p:cNvSpPr>
+            <a:spLocks noGrp="1"/>
+          </p:cNvSpPr>
+          <p:nvPr>
+            <p:ph type="sldNum" sz="quarter" idx="10"/>
+          </p:nvPr>
+        </p:nvSpPr>
+        <p:spPr/>
+        <p:txBody>
+          <a:bodyPr/>
+          <a:lstStyle/>
+          <a:p>
+            <a:fld id="{F7021451-1387-4CA6-816F-3879F97B5CBC}" type="slidenum">
+              <a:rPr lang="en-US"/>
+              <a:t>17</a:t>
             </a:fld>
             <a:endParaRPr lang="en-US"/>
           </a:p>
@@ -5939,6 +6117,3333 @@
     <p:bg>
       <p:bgPr>
         <a:solidFill>
+          <a:srgbClr val="F3F6F9"/>
+        </a:solidFill>
+      </p:bgPr>
+    </p:bg>
+    <p:spTree>
+      <p:nvGrpSpPr>
+        <p:cNvPr id="1" name=""/>
+        <p:cNvGrpSpPr/>
+        <p:nvPr/>
+      </p:nvGrpSpPr>
+      <p:grpSpPr>
+        <a:xfrm>
+          <a:off x="0" y="0"/>
+          <a:ext cx="0" cy="0"/>
+          <a:chOff x="0" y="0"/>
+          <a:chExt cx="0" cy="0"/>
+        </a:xfrm>
+      </p:grpSpPr>
+      <p:sp>
+        <p:nvSpPr>
+          <p:cNvPr id="2" name="Text 0"/>
+          <p:cNvSpPr/>
+          <p:nvPr/>
+        </p:nvSpPr>
+        <p:spPr>
+          <a:xfrm>
+            <a:off x="548640" y="256032"/>
+            <a:ext cx="11064240" cy="274320"/>
+          </a:xfrm>
+          <a:prstGeom prst="rect">
+            <a:avLst/>
+          </a:prstGeom>
+          <a:noFill/>
+          <a:ln/>
+        </p:spPr>
+        <p:txBody>
+          <a:bodyPr wrap="square" lIns="0" tIns="0" rIns="0" bIns="0" rtlCol="0" anchor="ctr"/>
+          <a:lstStyle/>
+          <a:p>
+            <a:pPr indent="0" marL="0">
+              <a:buNone/>
+            </a:pPr>
+            <a:r>
+              <a:rPr lang="en-US" sz="1200" b="1" spc="200" kern="0" dirty="0">
+                <a:solidFill>
+                  <a:srgbClr val="1C7293"/>
+                </a:solidFill>
+                <a:latin typeface="Calibri" pitchFamily="34" charset="0"/>
+                <a:ea typeface="Calibri" pitchFamily="34" charset="-122"/>
+                <a:cs typeface="Calibri" pitchFamily="34" charset="-120"/>
+              </a:rPr>
+              <a:t>APPENDIX · UNIT ECONOMICS</a:t>
+            </a:r>
+            <a:endParaRPr lang="en-US" sz="1200" dirty="0"/>
+          </a:p>
+        </p:txBody>
+      </p:sp>
+      <p:sp>
+        <p:nvSpPr>
+          <p:cNvPr id="3" name="Text 1"/>
+          <p:cNvSpPr/>
+          <p:nvPr/>
+        </p:nvSpPr>
+        <p:spPr>
+          <a:xfrm>
+            <a:off x="548640" y="411480"/>
+            <a:ext cx="11064240" cy="822960"/>
+          </a:xfrm>
+          <a:prstGeom prst="rect">
+            <a:avLst/>
+          </a:prstGeom>
+          <a:noFill/>
+          <a:ln/>
+        </p:spPr>
+        <p:txBody>
+          <a:bodyPr wrap="square" lIns="0" tIns="0" rIns="0" bIns="0" rtlCol="0" anchor="ctr"/>
+          <a:lstStyle/>
+          <a:p>
+            <a:pPr algn="l" indent="0" marL="0">
+              <a:buNone/>
+            </a:pPr>
+            <a:r>
+              <a:rPr lang="en-US" sz="3200" b="1" dirty="0">
+                <a:solidFill>
+                  <a:srgbClr val="1A2230"/>
+                </a:solidFill>
+                <a:latin typeface="Cambria" pitchFamily="34" charset="0"/>
+                <a:ea typeface="Cambria" pitchFamily="34" charset="-122"/>
+                <a:cs typeface="Cambria" pitchFamily="34" charset="-120"/>
+              </a:rPr>
+              <a:t>Where the ₱99,500 goes</a:t>
+            </a:r>
+            <a:endParaRPr lang="en-US" sz="3200" dirty="0"/>
+          </a:p>
+        </p:txBody>
+      </p:sp>
+      <p:graphicFrame>
+        <p:nvGraphicFramePr>
+          <p:cNvPr id="16" name="Table 0"/>
+          <p:cNvGraphicFramePr>
+            <a:graphicFrameLocks noGrp="1"/>
+          </p:cNvGraphicFramePr>
+          <p:nvPr>
+            <p:extLst>
+              <p:ext uri="{D42A27DB-BD31-4B8C-83A1-F6EECF244321}">
+                <p14:modId xmlns:p14="http://schemas.microsoft.com/office/powerpoint/2010/main" val="1579011935"/>
+              </p:ext>
+            </p:extLst>
+          </p:nvPr>
+        </p:nvGraphicFramePr>
+        <p:xfrm>
+          <a:off x="548640" y="1600200"/>
+          <a:ext cx="7680960" cy="914400"/>
+        </p:xfrm>
+        <a:graphic>
+          <a:graphicData uri="http://schemas.openxmlformats.org/drawingml/2006/table">
+            <a:tbl>
+              <a:tblPr/>
+              <a:tblGrid>
+                <a:gridCol w="3840480"/>
+                <a:gridCol w="1920240"/>
+                <a:gridCol w="1920240"/>
+              </a:tblGrid>
+              <a:tr h="402336">
+                <a:tc>
+                  <a:txBody>
+                    <a:bodyPr/>
+                    <a:lstStyle/>
+                    <a:p>
+                      <a:pPr algn="l" indent="0" marL="0">
+                        <a:buNone/>
+                      </a:pPr>
+                      <a:r>
+                        <a:rPr lang="en-US" sz="1400" b="1" dirty="0">
+                          <a:solidFill>
+                            <a:srgbClr val="F2B705"/>
+                          </a:solidFill>
+                          <a:latin typeface="Cambria" pitchFamily="34" charset="0"/>
+                          <a:ea typeface="Cambria" pitchFamily="34" charset="-122"/>
+                          <a:cs typeface="Cambria" pitchFamily="34" charset="-120"/>
+                        </a:rPr>
+                        <a:t>Line item</a:t>
+                      </a:r>
+                      <a:endParaRPr lang="en-US" sz="1400" dirty="0">
+                        <a:latin typeface="Cambria" charset="0"/>
+                        <a:ea typeface="Cambria" charset="0"/>
+                        <a:cs typeface="Cambria" charset="0"/>
+                      </a:endParaRPr>
+                    </a:p>
+                  </a:txBody>
+                  <a:tcPr marL="76200" marR="76200" marT="38100" marB="38100" anchor="ctr">
+                    <a:lnL w="12700" cap="flat" cmpd="sng" algn="ctr">
+                      <a:solidFill>
+                        <a:srgbClr val="DBE3EA"/>
+                      </a:solidFill>
+                      <a:prstDash val="solid"/>
+                      <a:round/>
+                      <a:headEnd type="none" w="med" len="med"/>
+                      <a:tailEnd type="none" w="med" len="med"/>
+                    </a:lnL>
+                    <a:lnR w="12700" cap="flat" cmpd="sng" algn="ctr">
+                      <a:solidFill>
+                        <a:srgbClr val="DBE3EA"/>
+                      </a:solidFill>
+                      <a:prstDash val="solid"/>
+                      <a:round/>
+                      <a:headEnd type="none" w="med" len="med"/>
+                      <a:tailEnd type="none" w="med" len="med"/>
+                    </a:lnR>
+                    <a:lnT w="12700" cap="flat" cmpd="sng" algn="ctr">
+                      <a:solidFill>
+                        <a:srgbClr val="DBE3EA"/>
+                      </a:solidFill>
+                      <a:prstDash val="solid"/>
+                      <a:round/>
+                      <a:headEnd type="none" w="med" len="med"/>
+                      <a:tailEnd type="none" w="med" len="med"/>
+                    </a:lnT>
+                    <a:lnB w="12700" cap="flat" cmpd="sng" algn="ctr">
+                      <a:solidFill>
+                        <a:srgbClr val="DBE3EA"/>
+                      </a:solidFill>
+                      <a:prstDash val="solid"/>
+                      <a:round/>
+                      <a:headEnd type="none" w="med" len="med"/>
+                      <a:tailEnd type="none" w="med" len="med"/>
+                    </a:lnB>
+                    <a:solidFill>
+                      <a:srgbClr val="12233A"/>
+                    </a:solidFill>
+                  </a:tcPr>
+                </a:tc>
+                <a:tc>
+                  <a:txBody>
+                    <a:bodyPr/>
+                    <a:lstStyle/>
+                    <a:p>
+                      <a:pPr algn="r" indent="0" marL="0">
+                        <a:buNone/>
+                      </a:pPr>
+                      <a:r>
+                        <a:rPr lang="en-US" sz="1400" b="1" dirty="0">
+                          <a:solidFill>
+                            <a:srgbClr val="F2B705"/>
+                          </a:solidFill>
+                          <a:latin typeface="Cambria" pitchFamily="34" charset="0"/>
+                          <a:ea typeface="Cambria" pitchFamily="34" charset="-122"/>
+                          <a:cs typeface="Cambria" pitchFamily="34" charset="-120"/>
+                        </a:rPr>
+                        <a:t>On-grid 2.3 kWp</a:t>
+                      </a:r>
+                      <a:endParaRPr lang="en-US" sz="1400" dirty="0">
+                        <a:latin typeface="Cambria" charset="0"/>
+                        <a:ea typeface="Cambria" charset="0"/>
+                        <a:cs typeface="Cambria" charset="0"/>
+                      </a:endParaRPr>
+                    </a:p>
+                  </a:txBody>
+                  <a:tcPr marL="76200" marR="76200" marT="38100" marB="38100" anchor="ctr">
+                    <a:lnL w="12700" cap="flat" cmpd="sng" algn="ctr">
+                      <a:solidFill>
+                        <a:srgbClr val="DBE3EA"/>
+                      </a:solidFill>
+                      <a:prstDash val="solid"/>
+                      <a:round/>
+                      <a:headEnd type="none" w="med" len="med"/>
+                      <a:tailEnd type="none" w="med" len="med"/>
+                    </a:lnL>
+                    <a:lnR w="12700" cap="flat" cmpd="sng" algn="ctr">
+                      <a:solidFill>
+                        <a:srgbClr val="DBE3EA"/>
+                      </a:solidFill>
+                      <a:prstDash val="solid"/>
+                      <a:round/>
+                      <a:headEnd type="none" w="med" len="med"/>
+                      <a:tailEnd type="none" w="med" len="med"/>
+                    </a:lnR>
+                    <a:lnT w="12700" cap="flat" cmpd="sng" algn="ctr">
+                      <a:solidFill>
+                        <a:srgbClr val="DBE3EA"/>
+                      </a:solidFill>
+                      <a:prstDash val="solid"/>
+                      <a:round/>
+                      <a:headEnd type="none" w="med" len="med"/>
+                      <a:tailEnd type="none" w="med" len="med"/>
+                    </a:lnT>
+                    <a:lnB w="12700" cap="flat" cmpd="sng" algn="ctr">
+                      <a:solidFill>
+                        <a:srgbClr val="DBE3EA"/>
+                      </a:solidFill>
+                      <a:prstDash val="solid"/>
+                      <a:round/>
+                      <a:headEnd type="none" w="med" len="med"/>
+                      <a:tailEnd type="none" w="med" len="med"/>
+                    </a:lnB>
+                    <a:solidFill>
+                      <a:srgbClr val="12233A"/>
+                    </a:solidFill>
+                  </a:tcPr>
+                </a:tc>
+                <a:tc>
+                  <a:txBody>
+                    <a:bodyPr/>
+                    <a:lstStyle/>
+                    <a:p>
+                      <a:pPr algn="r" indent="0" marL="0">
+                        <a:buNone/>
+                      </a:pPr>
+                      <a:r>
+                        <a:rPr lang="en-US" sz="1400" b="1" dirty="0">
+                          <a:solidFill>
+                            <a:srgbClr val="F2B705"/>
+                          </a:solidFill>
+                          <a:latin typeface="Cambria" pitchFamily="34" charset="0"/>
+                          <a:ea typeface="Cambria" pitchFamily="34" charset="-122"/>
+                          <a:cs typeface="Cambria" pitchFamily="34" charset="-120"/>
+                        </a:rPr>
+                        <a:t>Off-grid 1.6 kWp</a:t>
+                      </a:r>
+                      <a:endParaRPr lang="en-US" sz="1400" dirty="0">
+                        <a:latin typeface="Cambria" charset="0"/>
+                        <a:ea typeface="Cambria" charset="0"/>
+                        <a:cs typeface="Cambria" charset="0"/>
+                      </a:endParaRPr>
+                    </a:p>
+                  </a:txBody>
+                  <a:tcPr marL="76200" marR="76200" marT="38100" marB="38100" anchor="ctr">
+                    <a:lnL w="12700" cap="flat" cmpd="sng" algn="ctr">
+                      <a:solidFill>
+                        <a:srgbClr val="DBE3EA"/>
+                      </a:solidFill>
+                      <a:prstDash val="solid"/>
+                      <a:round/>
+                      <a:headEnd type="none" w="med" len="med"/>
+                      <a:tailEnd type="none" w="med" len="med"/>
+                    </a:lnL>
+                    <a:lnR w="12700" cap="flat" cmpd="sng" algn="ctr">
+                      <a:solidFill>
+                        <a:srgbClr val="DBE3EA"/>
+                      </a:solidFill>
+                      <a:prstDash val="solid"/>
+                      <a:round/>
+                      <a:headEnd type="none" w="med" len="med"/>
+                      <a:tailEnd type="none" w="med" len="med"/>
+                    </a:lnR>
+                    <a:lnT w="12700" cap="flat" cmpd="sng" algn="ctr">
+                      <a:solidFill>
+                        <a:srgbClr val="DBE3EA"/>
+                      </a:solidFill>
+                      <a:prstDash val="solid"/>
+                      <a:round/>
+                      <a:headEnd type="none" w="med" len="med"/>
+                      <a:tailEnd type="none" w="med" len="med"/>
+                    </a:lnT>
+                    <a:lnB w="12700" cap="flat" cmpd="sng" algn="ctr">
+                      <a:solidFill>
+                        <a:srgbClr val="DBE3EA"/>
+                      </a:solidFill>
+                      <a:prstDash val="solid"/>
+                      <a:round/>
+                      <a:headEnd type="none" w="med" len="med"/>
+                      <a:tailEnd type="none" w="med" len="med"/>
+                    </a:lnB>
+                    <a:solidFill>
+                      <a:srgbClr val="12233A"/>
+                    </a:solidFill>
+                  </a:tcPr>
+                </a:tc>
+              </a:tr>
+              <a:tr h="402336">
+                <a:tc>
+                  <a:txBody>
+                    <a:bodyPr/>
+                    <a:lstStyle/>
+                    <a:p>
+                      <a:pPr algn="l" indent="0" marL="0">
+                        <a:buNone/>
+                      </a:pPr>
+                      <a:r>
+                        <a:rPr lang="en-US" sz="1350" dirty="0">
+                          <a:solidFill>
+                            <a:srgbClr val="1A2230"/>
+                          </a:solidFill>
+                          <a:latin typeface="Calibri" pitchFamily="34" charset="0"/>
+                          <a:ea typeface="Calibri" pitchFamily="34" charset="-122"/>
+                          <a:cs typeface="Calibri" pitchFamily="34" charset="-120"/>
+                        </a:rPr>
+                        <a:t>Panels (bought)</a:t>
+                      </a:r>
+                      <a:endParaRPr lang="en-US" sz="1350" dirty="0">
+                        <a:latin typeface="Calibri" charset="0"/>
+                        <a:ea typeface="Calibri" charset="0"/>
+                        <a:cs typeface="Calibri" charset="0"/>
+                      </a:endParaRPr>
+                    </a:p>
+                  </a:txBody>
+                  <a:tcPr marL="76200" marR="76200" marT="38100" marB="38100" anchor="ctr">
+                    <a:lnL w="12700" cap="flat" cmpd="sng" algn="ctr">
+                      <a:solidFill>
+                        <a:srgbClr val="DBE3EA"/>
+                      </a:solidFill>
+                      <a:prstDash val="solid"/>
+                      <a:round/>
+                      <a:headEnd type="none" w="med" len="med"/>
+                      <a:tailEnd type="none" w="med" len="med"/>
+                    </a:lnL>
+                    <a:lnR w="12700" cap="flat" cmpd="sng" algn="ctr">
+                      <a:solidFill>
+                        <a:srgbClr val="DBE3EA"/>
+                      </a:solidFill>
+                      <a:prstDash val="solid"/>
+                      <a:round/>
+                      <a:headEnd type="none" w="med" len="med"/>
+                      <a:tailEnd type="none" w="med" len="med"/>
+                    </a:lnR>
+                    <a:lnT w="12700" cap="flat" cmpd="sng" algn="ctr">
+                      <a:solidFill>
+                        <a:srgbClr val="DBE3EA"/>
+                      </a:solidFill>
+                      <a:prstDash val="solid"/>
+                      <a:round/>
+                      <a:headEnd type="none" w="med" len="med"/>
+                      <a:tailEnd type="none" w="med" len="med"/>
+                    </a:lnT>
+                    <a:lnB w="12700" cap="flat" cmpd="sng" algn="ctr">
+                      <a:solidFill>
+                        <a:srgbClr val="DBE3EA"/>
+                      </a:solidFill>
+                      <a:prstDash val="solid"/>
+                      <a:round/>
+                      <a:headEnd type="none" w="med" len="med"/>
+                      <a:tailEnd type="none" w="med" len="med"/>
+                    </a:lnB>
+                  </a:tcPr>
+                </a:tc>
+                <a:tc>
+                  <a:txBody>
+                    <a:bodyPr/>
+                    <a:lstStyle/>
+                    <a:p>
+                      <a:pPr algn="r" indent="0" marL="0">
+                        <a:buNone/>
+                      </a:pPr>
+                      <a:r>
+                        <a:rPr lang="en-US" sz="1350" dirty="0">
+                          <a:solidFill>
+                            <a:srgbClr val="1A2230"/>
+                          </a:solidFill>
+                          <a:latin typeface="Calibri" pitchFamily="34" charset="0"/>
+                          <a:ea typeface="Calibri" pitchFamily="34" charset="-122"/>
+                          <a:cs typeface="Calibri" pitchFamily="34" charset="-120"/>
+                        </a:rPr>
+                        <a:t>₱23–28k</a:t>
+                      </a:r>
+                      <a:endParaRPr lang="en-US" sz="1350" dirty="0">
+                        <a:latin typeface="Calibri" charset="0"/>
+                        <a:ea typeface="Calibri" charset="0"/>
+                        <a:cs typeface="Calibri" charset="0"/>
+                      </a:endParaRPr>
+                    </a:p>
+                  </a:txBody>
+                  <a:tcPr marL="76200" marR="76200" marT="38100" marB="38100" anchor="ctr">
+                    <a:lnL w="12700" cap="flat" cmpd="sng" algn="ctr">
+                      <a:solidFill>
+                        <a:srgbClr val="DBE3EA"/>
+                      </a:solidFill>
+                      <a:prstDash val="solid"/>
+                      <a:round/>
+                      <a:headEnd type="none" w="med" len="med"/>
+                      <a:tailEnd type="none" w="med" len="med"/>
+                    </a:lnL>
+                    <a:lnR w="12700" cap="flat" cmpd="sng" algn="ctr">
+                      <a:solidFill>
+                        <a:srgbClr val="DBE3EA"/>
+                      </a:solidFill>
+                      <a:prstDash val="solid"/>
+                      <a:round/>
+                      <a:headEnd type="none" w="med" len="med"/>
+                      <a:tailEnd type="none" w="med" len="med"/>
+                    </a:lnR>
+                    <a:lnT w="12700" cap="flat" cmpd="sng" algn="ctr">
+                      <a:solidFill>
+                        <a:srgbClr val="DBE3EA"/>
+                      </a:solidFill>
+                      <a:prstDash val="solid"/>
+                      <a:round/>
+                      <a:headEnd type="none" w="med" len="med"/>
+                      <a:tailEnd type="none" w="med" len="med"/>
+                    </a:lnT>
+                    <a:lnB w="12700" cap="flat" cmpd="sng" algn="ctr">
+                      <a:solidFill>
+                        <a:srgbClr val="DBE3EA"/>
+                      </a:solidFill>
+                      <a:prstDash val="solid"/>
+                      <a:round/>
+                      <a:headEnd type="none" w="med" len="med"/>
+                      <a:tailEnd type="none" w="med" len="med"/>
+                    </a:lnB>
+                  </a:tcPr>
+                </a:tc>
+                <a:tc>
+                  <a:txBody>
+                    <a:bodyPr/>
+                    <a:lstStyle/>
+                    <a:p>
+                      <a:pPr algn="r" indent="0" marL="0">
+                        <a:buNone/>
+                      </a:pPr>
+                      <a:r>
+                        <a:rPr lang="en-US" sz="1350" dirty="0">
+                          <a:solidFill>
+                            <a:srgbClr val="1A2230"/>
+                          </a:solidFill>
+                          <a:latin typeface="Calibri" pitchFamily="34" charset="0"/>
+                          <a:ea typeface="Calibri" pitchFamily="34" charset="-122"/>
+                          <a:cs typeface="Calibri" pitchFamily="34" charset="-120"/>
+                        </a:rPr>
+                        <a:t>₱16–20k</a:t>
+                      </a:r>
+                      <a:endParaRPr lang="en-US" sz="1350" dirty="0">
+                        <a:latin typeface="Calibri" charset="0"/>
+                        <a:ea typeface="Calibri" charset="0"/>
+                        <a:cs typeface="Calibri" charset="0"/>
+                      </a:endParaRPr>
+                    </a:p>
+                  </a:txBody>
+                  <a:tcPr marL="76200" marR="76200" marT="38100" marB="38100" anchor="ctr">
+                    <a:lnL w="12700" cap="flat" cmpd="sng" algn="ctr">
+                      <a:solidFill>
+                        <a:srgbClr val="DBE3EA"/>
+                      </a:solidFill>
+                      <a:prstDash val="solid"/>
+                      <a:round/>
+                      <a:headEnd type="none" w="med" len="med"/>
+                      <a:tailEnd type="none" w="med" len="med"/>
+                    </a:lnL>
+                    <a:lnR w="12700" cap="flat" cmpd="sng" algn="ctr">
+                      <a:solidFill>
+                        <a:srgbClr val="DBE3EA"/>
+                      </a:solidFill>
+                      <a:prstDash val="solid"/>
+                      <a:round/>
+                      <a:headEnd type="none" w="med" len="med"/>
+                      <a:tailEnd type="none" w="med" len="med"/>
+                    </a:lnR>
+                    <a:lnT w="12700" cap="flat" cmpd="sng" algn="ctr">
+                      <a:solidFill>
+                        <a:srgbClr val="DBE3EA"/>
+                      </a:solidFill>
+                      <a:prstDash val="solid"/>
+                      <a:round/>
+                      <a:headEnd type="none" w="med" len="med"/>
+                      <a:tailEnd type="none" w="med" len="med"/>
+                    </a:lnT>
+                    <a:lnB w="12700" cap="flat" cmpd="sng" algn="ctr">
+                      <a:solidFill>
+                        <a:srgbClr val="DBE3EA"/>
+                      </a:solidFill>
+                      <a:prstDash val="solid"/>
+                      <a:round/>
+                      <a:headEnd type="none" w="med" len="med"/>
+                      <a:tailEnd type="none" w="med" len="med"/>
+                    </a:lnB>
+                  </a:tcPr>
+                </a:tc>
+              </a:tr>
+              <a:tr h="402336">
+                <a:tc>
+                  <a:txBody>
+                    <a:bodyPr/>
+                    <a:lstStyle/>
+                    <a:p>
+                      <a:pPr algn="l" indent="0" marL="0">
+                        <a:buNone/>
+                      </a:pPr>
+                      <a:r>
+                        <a:rPr lang="en-US" sz="1350" dirty="0">
+                          <a:solidFill>
+                            <a:srgbClr val="1A2230"/>
+                          </a:solidFill>
+                          <a:latin typeface="Calibri" pitchFamily="34" charset="0"/>
+                          <a:ea typeface="Calibri" pitchFamily="34" charset="-122"/>
+                          <a:cs typeface="Calibri" pitchFamily="34" charset="-120"/>
+                        </a:rPr>
+                        <a:t>Inverter (bought)</a:t>
+                      </a:r>
+                      <a:endParaRPr lang="en-US" sz="1350" dirty="0">
+                        <a:latin typeface="Calibri" charset="0"/>
+                        <a:ea typeface="Calibri" charset="0"/>
+                        <a:cs typeface="Calibri" charset="0"/>
+                      </a:endParaRPr>
+                    </a:p>
+                  </a:txBody>
+                  <a:tcPr marL="76200" marR="76200" marT="38100" marB="38100" anchor="ctr">
+                    <a:lnL w="12700" cap="flat" cmpd="sng" algn="ctr">
+                      <a:solidFill>
+                        <a:srgbClr val="DBE3EA"/>
+                      </a:solidFill>
+                      <a:prstDash val="solid"/>
+                      <a:round/>
+                      <a:headEnd type="none" w="med" len="med"/>
+                      <a:tailEnd type="none" w="med" len="med"/>
+                    </a:lnL>
+                    <a:lnR w="12700" cap="flat" cmpd="sng" algn="ctr">
+                      <a:solidFill>
+                        <a:srgbClr val="DBE3EA"/>
+                      </a:solidFill>
+                      <a:prstDash val="solid"/>
+                      <a:round/>
+                      <a:headEnd type="none" w="med" len="med"/>
+                      <a:tailEnd type="none" w="med" len="med"/>
+                    </a:lnR>
+                    <a:lnT w="12700" cap="flat" cmpd="sng" algn="ctr">
+                      <a:solidFill>
+                        <a:srgbClr val="DBE3EA"/>
+                      </a:solidFill>
+                      <a:prstDash val="solid"/>
+                      <a:round/>
+                      <a:headEnd type="none" w="med" len="med"/>
+                      <a:tailEnd type="none" w="med" len="med"/>
+                    </a:lnT>
+                    <a:lnB w="12700" cap="flat" cmpd="sng" algn="ctr">
+                      <a:solidFill>
+                        <a:srgbClr val="DBE3EA"/>
+                      </a:solidFill>
+                      <a:prstDash val="solid"/>
+                      <a:round/>
+                      <a:headEnd type="none" w="med" len="med"/>
+                      <a:tailEnd type="none" w="med" len="med"/>
+                    </a:lnB>
+                  </a:tcPr>
+                </a:tc>
+                <a:tc>
+                  <a:txBody>
+                    <a:bodyPr/>
+                    <a:lstStyle/>
+                    <a:p>
+                      <a:pPr algn="r" indent="0" marL="0">
+                        <a:buNone/>
+                      </a:pPr>
+                      <a:r>
+                        <a:rPr lang="en-US" sz="1350" dirty="0">
+                          <a:solidFill>
+                            <a:srgbClr val="1A2230"/>
+                          </a:solidFill>
+                          <a:latin typeface="Calibri" pitchFamily="34" charset="0"/>
+                          <a:ea typeface="Calibri" pitchFamily="34" charset="-122"/>
+                          <a:cs typeface="Calibri" pitchFamily="34" charset="-120"/>
+                        </a:rPr>
+                        <a:t>₱16–24k</a:t>
+                      </a:r>
+                      <a:endParaRPr lang="en-US" sz="1350" dirty="0">
+                        <a:latin typeface="Calibri" charset="0"/>
+                        <a:ea typeface="Calibri" charset="0"/>
+                        <a:cs typeface="Calibri" charset="0"/>
+                      </a:endParaRPr>
+                    </a:p>
+                  </a:txBody>
+                  <a:tcPr marL="76200" marR="76200" marT="38100" marB="38100" anchor="ctr">
+                    <a:lnL w="12700" cap="flat" cmpd="sng" algn="ctr">
+                      <a:solidFill>
+                        <a:srgbClr val="DBE3EA"/>
+                      </a:solidFill>
+                      <a:prstDash val="solid"/>
+                      <a:round/>
+                      <a:headEnd type="none" w="med" len="med"/>
+                      <a:tailEnd type="none" w="med" len="med"/>
+                    </a:lnL>
+                    <a:lnR w="12700" cap="flat" cmpd="sng" algn="ctr">
+                      <a:solidFill>
+                        <a:srgbClr val="DBE3EA"/>
+                      </a:solidFill>
+                      <a:prstDash val="solid"/>
+                      <a:round/>
+                      <a:headEnd type="none" w="med" len="med"/>
+                      <a:tailEnd type="none" w="med" len="med"/>
+                    </a:lnR>
+                    <a:lnT w="12700" cap="flat" cmpd="sng" algn="ctr">
+                      <a:solidFill>
+                        <a:srgbClr val="DBE3EA"/>
+                      </a:solidFill>
+                      <a:prstDash val="solid"/>
+                      <a:round/>
+                      <a:headEnd type="none" w="med" len="med"/>
+                      <a:tailEnd type="none" w="med" len="med"/>
+                    </a:lnT>
+                    <a:lnB w="12700" cap="flat" cmpd="sng" algn="ctr">
+                      <a:solidFill>
+                        <a:srgbClr val="DBE3EA"/>
+                      </a:solidFill>
+                      <a:prstDash val="solid"/>
+                      <a:round/>
+                      <a:headEnd type="none" w="med" len="med"/>
+                      <a:tailEnd type="none" w="med" len="med"/>
+                    </a:lnB>
+                  </a:tcPr>
+                </a:tc>
+                <a:tc>
+                  <a:txBody>
+                    <a:bodyPr/>
+                    <a:lstStyle/>
+                    <a:p>
+                      <a:pPr algn="r" indent="0" marL="0">
+                        <a:buNone/>
+                      </a:pPr>
+                      <a:r>
+                        <a:rPr lang="en-US" sz="1350" dirty="0">
+                          <a:solidFill>
+                            <a:srgbClr val="1A2230"/>
+                          </a:solidFill>
+                          <a:latin typeface="Calibri" pitchFamily="34" charset="0"/>
+                          <a:ea typeface="Calibri" pitchFamily="34" charset="-122"/>
+                          <a:cs typeface="Calibri" pitchFamily="34" charset="-120"/>
+                        </a:rPr>
+                        <a:t>₱18–26k</a:t>
+                      </a:r>
+                      <a:endParaRPr lang="en-US" sz="1350" dirty="0">
+                        <a:latin typeface="Calibri" charset="0"/>
+                        <a:ea typeface="Calibri" charset="0"/>
+                        <a:cs typeface="Calibri" charset="0"/>
+                      </a:endParaRPr>
+                    </a:p>
+                  </a:txBody>
+                  <a:tcPr marL="76200" marR="76200" marT="38100" marB="38100" anchor="ctr">
+                    <a:lnL w="12700" cap="flat" cmpd="sng" algn="ctr">
+                      <a:solidFill>
+                        <a:srgbClr val="DBE3EA"/>
+                      </a:solidFill>
+                      <a:prstDash val="solid"/>
+                      <a:round/>
+                      <a:headEnd type="none" w="med" len="med"/>
+                      <a:tailEnd type="none" w="med" len="med"/>
+                    </a:lnL>
+                    <a:lnR w="12700" cap="flat" cmpd="sng" algn="ctr">
+                      <a:solidFill>
+                        <a:srgbClr val="DBE3EA"/>
+                      </a:solidFill>
+                      <a:prstDash val="solid"/>
+                      <a:round/>
+                      <a:headEnd type="none" w="med" len="med"/>
+                      <a:tailEnd type="none" w="med" len="med"/>
+                    </a:lnR>
+                    <a:lnT w="12700" cap="flat" cmpd="sng" algn="ctr">
+                      <a:solidFill>
+                        <a:srgbClr val="DBE3EA"/>
+                      </a:solidFill>
+                      <a:prstDash val="solid"/>
+                      <a:round/>
+                      <a:headEnd type="none" w="med" len="med"/>
+                      <a:tailEnd type="none" w="med" len="med"/>
+                    </a:lnT>
+                    <a:lnB w="12700" cap="flat" cmpd="sng" algn="ctr">
+                      <a:solidFill>
+                        <a:srgbClr val="DBE3EA"/>
+                      </a:solidFill>
+                      <a:prstDash val="solid"/>
+                      <a:round/>
+                      <a:headEnd type="none" w="med" len="med"/>
+                      <a:tailEnd type="none" w="med" len="med"/>
+                    </a:lnB>
+                  </a:tcPr>
+                </a:tc>
+              </a:tr>
+              <a:tr h="402336">
+                <a:tc>
+                  <a:txBody>
+                    <a:bodyPr/>
+                    <a:lstStyle/>
+                    <a:p>
+                      <a:pPr algn="l" indent="0" marL="0">
+                        <a:buNone/>
+                      </a:pPr>
+                      <a:r>
+                        <a:rPr lang="en-US" sz="1350" dirty="0">
+                          <a:solidFill>
+                            <a:srgbClr val="1A2230"/>
+                          </a:solidFill>
+                          <a:latin typeface="Calibri" pitchFamily="34" charset="0"/>
+                          <a:ea typeface="Calibri" pitchFamily="34" charset="-122"/>
+                          <a:cs typeface="Calibri" pitchFamily="34" charset="-120"/>
+                        </a:rPr>
+                        <a:t>Battery (bought)</a:t>
+                      </a:r>
+                      <a:endParaRPr lang="en-US" sz="1350" dirty="0">
+                        <a:latin typeface="Calibri" charset="0"/>
+                        <a:ea typeface="Calibri" charset="0"/>
+                        <a:cs typeface="Calibri" charset="0"/>
+                      </a:endParaRPr>
+                    </a:p>
+                  </a:txBody>
+                  <a:tcPr marL="76200" marR="76200" marT="38100" marB="38100" anchor="ctr">
+                    <a:lnL w="12700" cap="flat" cmpd="sng" algn="ctr">
+                      <a:solidFill>
+                        <a:srgbClr val="DBE3EA"/>
+                      </a:solidFill>
+                      <a:prstDash val="solid"/>
+                      <a:round/>
+                      <a:headEnd type="none" w="med" len="med"/>
+                      <a:tailEnd type="none" w="med" len="med"/>
+                    </a:lnL>
+                    <a:lnR w="12700" cap="flat" cmpd="sng" algn="ctr">
+                      <a:solidFill>
+                        <a:srgbClr val="DBE3EA"/>
+                      </a:solidFill>
+                      <a:prstDash val="solid"/>
+                      <a:round/>
+                      <a:headEnd type="none" w="med" len="med"/>
+                      <a:tailEnd type="none" w="med" len="med"/>
+                    </a:lnR>
+                    <a:lnT w="12700" cap="flat" cmpd="sng" algn="ctr">
+                      <a:solidFill>
+                        <a:srgbClr val="DBE3EA"/>
+                      </a:solidFill>
+                      <a:prstDash val="solid"/>
+                      <a:round/>
+                      <a:headEnd type="none" w="med" len="med"/>
+                      <a:tailEnd type="none" w="med" len="med"/>
+                    </a:lnT>
+                    <a:lnB w="12700" cap="flat" cmpd="sng" algn="ctr">
+                      <a:solidFill>
+                        <a:srgbClr val="DBE3EA"/>
+                      </a:solidFill>
+                      <a:prstDash val="solid"/>
+                      <a:round/>
+                      <a:headEnd type="none" w="med" len="med"/>
+                      <a:tailEnd type="none" w="med" len="med"/>
+                    </a:lnB>
+                  </a:tcPr>
+                </a:tc>
+                <a:tc>
+                  <a:txBody>
+                    <a:bodyPr/>
+                    <a:lstStyle/>
+                    <a:p>
+                      <a:pPr algn="r" indent="0" marL="0">
+                        <a:buNone/>
+                      </a:pPr>
+                      <a:r>
+                        <a:rPr lang="en-US" sz="1350" dirty="0">
+                          <a:solidFill>
+                            <a:srgbClr val="5C6B7A"/>
+                          </a:solidFill>
+                          <a:latin typeface="Calibri" pitchFamily="34" charset="0"/>
+                          <a:ea typeface="Calibri" pitchFamily="34" charset="-122"/>
+                          <a:cs typeface="Calibri" pitchFamily="34" charset="-120"/>
+                        </a:rPr>
+                        <a:t>—</a:t>
+                      </a:r>
+                      <a:endParaRPr lang="en-US" sz="1350" dirty="0">
+                        <a:latin typeface="Calibri" charset="0"/>
+                        <a:ea typeface="Calibri" charset="0"/>
+                        <a:cs typeface="Calibri" charset="0"/>
+                      </a:endParaRPr>
+                    </a:p>
+                  </a:txBody>
+                  <a:tcPr marL="76200" marR="76200" marT="38100" marB="38100" anchor="ctr">
+                    <a:lnL w="12700" cap="flat" cmpd="sng" algn="ctr">
+                      <a:solidFill>
+                        <a:srgbClr val="DBE3EA"/>
+                      </a:solidFill>
+                      <a:prstDash val="solid"/>
+                      <a:round/>
+                      <a:headEnd type="none" w="med" len="med"/>
+                      <a:tailEnd type="none" w="med" len="med"/>
+                    </a:lnL>
+                    <a:lnR w="12700" cap="flat" cmpd="sng" algn="ctr">
+                      <a:solidFill>
+                        <a:srgbClr val="DBE3EA"/>
+                      </a:solidFill>
+                      <a:prstDash val="solid"/>
+                      <a:round/>
+                      <a:headEnd type="none" w="med" len="med"/>
+                      <a:tailEnd type="none" w="med" len="med"/>
+                    </a:lnR>
+                    <a:lnT w="12700" cap="flat" cmpd="sng" algn="ctr">
+                      <a:solidFill>
+                        <a:srgbClr val="DBE3EA"/>
+                      </a:solidFill>
+                      <a:prstDash val="solid"/>
+                      <a:round/>
+                      <a:headEnd type="none" w="med" len="med"/>
+                      <a:tailEnd type="none" w="med" len="med"/>
+                    </a:lnT>
+                    <a:lnB w="12700" cap="flat" cmpd="sng" algn="ctr">
+                      <a:solidFill>
+                        <a:srgbClr val="DBE3EA"/>
+                      </a:solidFill>
+                      <a:prstDash val="solid"/>
+                      <a:round/>
+                      <a:headEnd type="none" w="med" len="med"/>
+                      <a:tailEnd type="none" w="med" len="med"/>
+                    </a:lnB>
+                  </a:tcPr>
+                </a:tc>
+                <a:tc>
+                  <a:txBody>
+                    <a:bodyPr/>
+                    <a:lstStyle/>
+                    <a:p>
+                      <a:pPr algn="r" indent="0" marL="0">
+                        <a:buNone/>
+                      </a:pPr>
+                      <a:r>
+                        <a:rPr lang="en-US" sz="1350" dirty="0">
+                          <a:solidFill>
+                            <a:srgbClr val="1A2230"/>
+                          </a:solidFill>
+                          <a:latin typeface="Calibri" pitchFamily="34" charset="0"/>
+                          <a:ea typeface="Calibri" pitchFamily="34" charset="-122"/>
+                          <a:cs typeface="Calibri" pitchFamily="34" charset="-120"/>
+                        </a:rPr>
+                        <a:t>₱22–32k</a:t>
+                      </a:r>
+                      <a:endParaRPr lang="en-US" sz="1350" dirty="0">
+                        <a:latin typeface="Calibri" charset="0"/>
+                        <a:ea typeface="Calibri" charset="0"/>
+                        <a:cs typeface="Calibri" charset="0"/>
+                      </a:endParaRPr>
+                    </a:p>
+                  </a:txBody>
+                  <a:tcPr marL="76200" marR="76200" marT="38100" marB="38100" anchor="ctr">
+                    <a:lnL w="12700" cap="flat" cmpd="sng" algn="ctr">
+                      <a:solidFill>
+                        <a:srgbClr val="DBE3EA"/>
+                      </a:solidFill>
+                      <a:prstDash val="solid"/>
+                      <a:round/>
+                      <a:headEnd type="none" w="med" len="med"/>
+                      <a:tailEnd type="none" w="med" len="med"/>
+                    </a:lnL>
+                    <a:lnR w="12700" cap="flat" cmpd="sng" algn="ctr">
+                      <a:solidFill>
+                        <a:srgbClr val="DBE3EA"/>
+                      </a:solidFill>
+                      <a:prstDash val="solid"/>
+                      <a:round/>
+                      <a:headEnd type="none" w="med" len="med"/>
+                      <a:tailEnd type="none" w="med" len="med"/>
+                    </a:lnR>
+                    <a:lnT w="12700" cap="flat" cmpd="sng" algn="ctr">
+                      <a:solidFill>
+                        <a:srgbClr val="DBE3EA"/>
+                      </a:solidFill>
+                      <a:prstDash val="solid"/>
+                      <a:round/>
+                      <a:headEnd type="none" w="med" len="med"/>
+                      <a:tailEnd type="none" w="med" len="med"/>
+                    </a:lnT>
+                    <a:lnB w="12700" cap="flat" cmpd="sng" algn="ctr">
+                      <a:solidFill>
+                        <a:srgbClr val="DBE3EA"/>
+                      </a:solidFill>
+                      <a:prstDash val="solid"/>
+                      <a:round/>
+                      <a:headEnd type="none" w="med" len="med"/>
+                      <a:tailEnd type="none" w="med" len="med"/>
+                    </a:lnB>
+                  </a:tcPr>
+                </a:tc>
+              </a:tr>
+              <a:tr h="402336">
+                <a:tc>
+                  <a:txBody>
+                    <a:bodyPr/>
+                    <a:lstStyle/>
+                    <a:p>
+                      <a:pPr algn="l" indent="0" marL="0">
+                        <a:buNone/>
+                      </a:pPr>
+                      <a:r>
+                        <a:rPr lang="en-US" sz="1350" b="1" dirty="0">
+                          <a:solidFill>
+                            <a:srgbClr val="1C7293"/>
+                          </a:solidFill>
+                          <a:latin typeface="Calibri" pitchFamily="34" charset="0"/>
+                          <a:ea typeface="Calibri" pitchFamily="34" charset="-122"/>
+                          <a:cs typeface="Calibri" pitchFamily="34" charset="-120"/>
+                        </a:rPr>
+                        <a:t>Racking + boxes + harness (built)</a:t>
+                      </a:r>
+                      <a:endParaRPr lang="en-US" sz="1350" dirty="0">
+                        <a:latin typeface="Calibri" charset="0"/>
+                        <a:ea typeface="Calibri" charset="0"/>
+                        <a:cs typeface="Calibri" charset="0"/>
+                      </a:endParaRPr>
+                    </a:p>
+                  </a:txBody>
+                  <a:tcPr marL="76200" marR="76200" marT="38100" marB="38100" anchor="ctr">
+                    <a:lnL w="12700" cap="flat" cmpd="sng" algn="ctr">
+                      <a:solidFill>
+                        <a:srgbClr val="DBE3EA"/>
+                      </a:solidFill>
+                      <a:prstDash val="solid"/>
+                      <a:round/>
+                      <a:headEnd type="none" w="med" len="med"/>
+                      <a:tailEnd type="none" w="med" len="med"/>
+                    </a:lnL>
+                    <a:lnR w="12700" cap="flat" cmpd="sng" algn="ctr">
+                      <a:solidFill>
+                        <a:srgbClr val="DBE3EA"/>
+                      </a:solidFill>
+                      <a:prstDash val="solid"/>
+                      <a:round/>
+                      <a:headEnd type="none" w="med" len="med"/>
+                      <a:tailEnd type="none" w="med" len="med"/>
+                    </a:lnR>
+                    <a:lnT w="12700" cap="flat" cmpd="sng" algn="ctr">
+                      <a:solidFill>
+                        <a:srgbClr val="DBE3EA"/>
+                      </a:solidFill>
+                      <a:prstDash val="solid"/>
+                      <a:round/>
+                      <a:headEnd type="none" w="med" len="med"/>
+                      <a:tailEnd type="none" w="med" len="med"/>
+                    </a:lnT>
+                    <a:lnB w="12700" cap="flat" cmpd="sng" algn="ctr">
+                      <a:solidFill>
+                        <a:srgbClr val="DBE3EA"/>
+                      </a:solidFill>
+                      <a:prstDash val="solid"/>
+                      <a:round/>
+                      <a:headEnd type="none" w="med" len="med"/>
+                      <a:tailEnd type="none" w="med" len="med"/>
+                    </a:lnB>
+                  </a:tcPr>
+                </a:tc>
+                <a:tc>
+                  <a:txBody>
+                    <a:bodyPr/>
+                    <a:lstStyle/>
+                    <a:p>
+                      <a:pPr algn="r" indent="0" marL="0">
+                        <a:buNone/>
+                      </a:pPr>
+                      <a:r>
+                        <a:rPr lang="en-US" sz="1350" b="1" dirty="0">
+                          <a:solidFill>
+                            <a:srgbClr val="1C7293"/>
+                          </a:solidFill>
+                          <a:latin typeface="Calibri" pitchFamily="34" charset="0"/>
+                          <a:ea typeface="Calibri" pitchFamily="34" charset="-122"/>
+                          <a:cs typeface="Calibri" pitchFamily="34" charset="-120"/>
+                        </a:rPr>
+                        <a:t>₱10–14k</a:t>
+                      </a:r>
+                      <a:endParaRPr lang="en-US" sz="1350" dirty="0">
+                        <a:latin typeface="Calibri" charset="0"/>
+                        <a:ea typeface="Calibri" charset="0"/>
+                        <a:cs typeface="Calibri" charset="0"/>
+                      </a:endParaRPr>
+                    </a:p>
+                  </a:txBody>
+                  <a:tcPr marL="76200" marR="76200" marT="38100" marB="38100" anchor="ctr">
+                    <a:lnL w="12700" cap="flat" cmpd="sng" algn="ctr">
+                      <a:solidFill>
+                        <a:srgbClr val="DBE3EA"/>
+                      </a:solidFill>
+                      <a:prstDash val="solid"/>
+                      <a:round/>
+                      <a:headEnd type="none" w="med" len="med"/>
+                      <a:tailEnd type="none" w="med" len="med"/>
+                    </a:lnL>
+                    <a:lnR w="12700" cap="flat" cmpd="sng" algn="ctr">
+                      <a:solidFill>
+                        <a:srgbClr val="DBE3EA"/>
+                      </a:solidFill>
+                      <a:prstDash val="solid"/>
+                      <a:round/>
+                      <a:headEnd type="none" w="med" len="med"/>
+                      <a:tailEnd type="none" w="med" len="med"/>
+                    </a:lnR>
+                    <a:lnT w="12700" cap="flat" cmpd="sng" algn="ctr">
+                      <a:solidFill>
+                        <a:srgbClr val="DBE3EA"/>
+                      </a:solidFill>
+                      <a:prstDash val="solid"/>
+                      <a:round/>
+                      <a:headEnd type="none" w="med" len="med"/>
+                      <a:tailEnd type="none" w="med" len="med"/>
+                    </a:lnT>
+                    <a:lnB w="12700" cap="flat" cmpd="sng" algn="ctr">
+                      <a:solidFill>
+                        <a:srgbClr val="DBE3EA"/>
+                      </a:solidFill>
+                      <a:prstDash val="solid"/>
+                      <a:round/>
+                      <a:headEnd type="none" w="med" len="med"/>
+                      <a:tailEnd type="none" w="med" len="med"/>
+                    </a:lnB>
+                  </a:tcPr>
+                </a:tc>
+                <a:tc>
+                  <a:txBody>
+                    <a:bodyPr/>
+                    <a:lstStyle/>
+                    <a:p>
+                      <a:pPr algn="r" indent="0" marL="0">
+                        <a:buNone/>
+                      </a:pPr>
+                      <a:r>
+                        <a:rPr lang="en-US" sz="1350" b="1" dirty="0">
+                          <a:solidFill>
+                            <a:srgbClr val="1C7293"/>
+                          </a:solidFill>
+                          <a:latin typeface="Calibri" pitchFamily="34" charset="0"/>
+                          <a:ea typeface="Calibri" pitchFamily="34" charset="-122"/>
+                          <a:cs typeface="Calibri" pitchFamily="34" charset="-120"/>
+                        </a:rPr>
+                        <a:t>₱9–13k</a:t>
+                      </a:r>
+                      <a:endParaRPr lang="en-US" sz="1350" dirty="0">
+                        <a:latin typeface="Calibri" charset="0"/>
+                        <a:ea typeface="Calibri" charset="0"/>
+                        <a:cs typeface="Calibri" charset="0"/>
+                      </a:endParaRPr>
+                    </a:p>
+                  </a:txBody>
+                  <a:tcPr marL="76200" marR="76200" marT="38100" marB="38100" anchor="ctr">
+                    <a:lnL w="12700" cap="flat" cmpd="sng" algn="ctr">
+                      <a:solidFill>
+                        <a:srgbClr val="DBE3EA"/>
+                      </a:solidFill>
+                      <a:prstDash val="solid"/>
+                      <a:round/>
+                      <a:headEnd type="none" w="med" len="med"/>
+                      <a:tailEnd type="none" w="med" len="med"/>
+                    </a:lnL>
+                    <a:lnR w="12700" cap="flat" cmpd="sng" algn="ctr">
+                      <a:solidFill>
+                        <a:srgbClr val="DBE3EA"/>
+                      </a:solidFill>
+                      <a:prstDash val="solid"/>
+                      <a:round/>
+                      <a:headEnd type="none" w="med" len="med"/>
+                      <a:tailEnd type="none" w="med" len="med"/>
+                    </a:lnR>
+                    <a:lnT w="12700" cap="flat" cmpd="sng" algn="ctr">
+                      <a:solidFill>
+                        <a:srgbClr val="DBE3EA"/>
+                      </a:solidFill>
+                      <a:prstDash val="solid"/>
+                      <a:round/>
+                      <a:headEnd type="none" w="med" len="med"/>
+                      <a:tailEnd type="none" w="med" len="med"/>
+                    </a:lnT>
+                    <a:lnB w="12700" cap="flat" cmpd="sng" algn="ctr">
+                      <a:solidFill>
+                        <a:srgbClr val="DBE3EA"/>
+                      </a:solidFill>
+                      <a:prstDash val="solid"/>
+                      <a:round/>
+                      <a:headEnd type="none" w="med" len="med"/>
+                      <a:tailEnd type="none" w="med" len="med"/>
+                    </a:lnB>
+                  </a:tcPr>
+                </a:tc>
+              </a:tr>
+              <a:tr h="402336">
+                <a:tc>
+                  <a:txBody>
+                    <a:bodyPr/>
+                    <a:lstStyle/>
+                    <a:p>
+                      <a:pPr algn="l" indent="0" marL="0">
+                        <a:buNone/>
+                      </a:pPr>
+                      <a:r>
+                        <a:rPr lang="en-US" sz="1350" dirty="0">
+                          <a:solidFill>
+                            <a:srgbClr val="1A2230"/>
+                          </a:solidFill>
+                          <a:latin typeface="Calibri" pitchFamily="34" charset="0"/>
+                          <a:ea typeface="Calibri" pitchFamily="34" charset="-122"/>
+                          <a:cs typeface="Calibri" pitchFamily="34" charset="-120"/>
+                        </a:rPr>
+                        <a:t>Labor + transport</a:t>
+                      </a:r>
+                      <a:endParaRPr lang="en-US" sz="1350" dirty="0">
+                        <a:latin typeface="Calibri" charset="0"/>
+                        <a:ea typeface="Calibri" charset="0"/>
+                        <a:cs typeface="Calibri" charset="0"/>
+                      </a:endParaRPr>
+                    </a:p>
+                  </a:txBody>
+                  <a:tcPr marL="76200" marR="76200" marT="38100" marB="38100" anchor="ctr">
+                    <a:lnL w="12700" cap="flat" cmpd="sng" algn="ctr">
+                      <a:solidFill>
+                        <a:srgbClr val="DBE3EA"/>
+                      </a:solidFill>
+                      <a:prstDash val="solid"/>
+                      <a:round/>
+                      <a:headEnd type="none" w="med" len="med"/>
+                      <a:tailEnd type="none" w="med" len="med"/>
+                    </a:lnL>
+                    <a:lnR w="12700" cap="flat" cmpd="sng" algn="ctr">
+                      <a:solidFill>
+                        <a:srgbClr val="DBE3EA"/>
+                      </a:solidFill>
+                      <a:prstDash val="solid"/>
+                      <a:round/>
+                      <a:headEnd type="none" w="med" len="med"/>
+                      <a:tailEnd type="none" w="med" len="med"/>
+                    </a:lnR>
+                    <a:lnT w="12700" cap="flat" cmpd="sng" algn="ctr">
+                      <a:solidFill>
+                        <a:srgbClr val="DBE3EA"/>
+                      </a:solidFill>
+                      <a:prstDash val="solid"/>
+                      <a:round/>
+                      <a:headEnd type="none" w="med" len="med"/>
+                      <a:tailEnd type="none" w="med" len="med"/>
+                    </a:lnT>
+                    <a:lnB w="12700" cap="flat" cmpd="sng" algn="ctr">
+                      <a:solidFill>
+                        <a:srgbClr val="DBE3EA"/>
+                      </a:solidFill>
+                      <a:prstDash val="solid"/>
+                      <a:round/>
+                      <a:headEnd type="none" w="med" len="med"/>
+                      <a:tailEnd type="none" w="med" len="med"/>
+                    </a:lnB>
+                  </a:tcPr>
+                </a:tc>
+                <a:tc>
+                  <a:txBody>
+                    <a:bodyPr/>
+                    <a:lstStyle/>
+                    <a:p>
+                      <a:pPr algn="r" indent="0" marL="0">
+                        <a:buNone/>
+                      </a:pPr>
+                      <a:r>
+                        <a:rPr lang="en-US" sz="1350" dirty="0">
+                          <a:solidFill>
+                            <a:srgbClr val="1A2230"/>
+                          </a:solidFill>
+                          <a:latin typeface="Calibri" pitchFamily="34" charset="0"/>
+                          <a:ea typeface="Calibri" pitchFamily="34" charset="-122"/>
+                          <a:cs typeface="Calibri" pitchFamily="34" charset="-120"/>
+                        </a:rPr>
+                        <a:t>₱7–10k</a:t>
+                      </a:r>
+                      <a:endParaRPr lang="en-US" sz="1350" dirty="0">
+                        <a:latin typeface="Calibri" charset="0"/>
+                        <a:ea typeface="Calibri" charset="0"/>
+                        <a:cs typeface="Calibri" charset="0"/>
+                      </a:endParaRPr>
+                    </a:p>
+                  </a:txBody>
+                  <a:tcPr marL="76200" marR="76200" marT="38100" marB="38100" anchor="ctr">
+                    <a:lnL w="12700" cap="flat" cmpd="sng" algn="ctr">
+                      <a:solidFill>
+                        <a:srgbClr val="DBE3EA"/>
+                      </a:solidFill>
+                      <a:prstDash val="solid"/>
+                      <a:round/>
+                      <a:headEnd type="none" w="med" len="med"/>
+                      <a:tailEnd type="none" w="med" len="med"/>
+                    </a:lnL>
+                    <a:lnR w="12700" cap="flat" cmpd="sng" algn="ctr">
+                      <a:solidFill>
+                        <a:srgbClr val="DBE3EA"/>
+                      </a:solidFill>
+                      <a:prstDash val="solid"/>
+                      <a:round/>
+                      <a:headEnd type="none" w="med" len="med"/>
+                      <a:tailEnd type="none" w="med" len="med"/>
+                    </a:lnR>
+                    <a:lnT w="12700" cap="flat" cmpd="sng" algn="ctr">
+                      <a:solidFill>
+                        <a:srgbClr val="DBE3EA"/>
+                      </a:solidFill>
+                      <a:prstDash val="solid"/>
+                      <a:round/>
+                      <a:headEnd type="none" w="med" len="med"/>
+                      <a:tailEnd type="none" w="med" len="med"/>
+                    </a:lnT>
+                    <a:lnB w="12700" cap="flat" cmpd="sng" algn="ctr">
+                      <a:solidFill>
+                        <a:srgbClr val="DBE3EA"/>
+                      </a:solidFill>
+                      <a:prstDash val="solid"/>
+                      <a:round/>
+                      <a:headEnd type="none" w="med" len="med"/>
+                      <a:tailEnd type="none" w="med" len="med"/>
+                    </a:lnB>
+                  </a:tcPr>
+                </a:tc>
+                <a:tc>
+                  <a:txBody>
+                    <a:bodyPr/>
+                    <a:lstStyle/>
+                    <a:p>
+                      <a:pPr algn="r" indent="0" marL="0">
+                        <a:buNone/>
+                      </a:pPr>
+                      <a:r>
+                        <a:rPr lang="en-US" sz="1350" dirty="0">
+                          <a:solidFill>
+                            <a:srgbClr val="1A2230"/>
+                          </a:solidFill>
+                          <a:latin typeface="Calibri" pitchFamily="34" charset="0"/>
+                          <a:ea typeface="Calibri" pitchFamily="34" charset="-122"/>
+                          <a:cs typeface="Calibri" pitchFamily="34" charset="-120"/>
+                        </a:rPr>
+                        <a:t>₱6–9k</a:t>
+                      </a:r>
+                      <a:endParaRPr lang="en-US" sz="1350" dirty="0">
+                        <a:latin typeface="Calibri" charset="0"/>
+                        <a:ea typeface="Calibri" charset="0"/>
+                        <a:cs typeface="Calibri" charset="0"/>
+                      </a:endParaRPr>
+                    </a:p>
+                  </a:txBody>
+                  <a:tcPr marL="76200" marR="76200" marT="38100" marB="38100" anchor="ctr">
+                    <a:lnL w="12700" cap="flat" cmpd="sng" algn="ctr">
+                      <a:solidFill>
+                        <a:srgbClr val="DBE3EA"/>
+                      </a:solidFill>
+                      <a:prstDash val="solid"/>
+                      <a:round/>
+                      <a:headEnd type="none" w="med" len="med"/>
+                      <a:tailEnd type="none" w="med" len="med"/>
+                    </a:lnL>
+                    <a:lnR w="12700" cap="flat" cmpd="sng" algn="ctr">
+                      <a:solidFill>
+                        <a:srgbClr val="DBE3EA"/>
+                      </a:solidFill>
+                      <a:prstDash val="solid"/>
+                      <a:round/>
+                      <a:headEnd type="none" w="med" len="med"/>
+                      <a:tailEnd type="none" w="med" len="med"/>
+                    </a:lnR>
+                    <a:lnT w="12700" cap="flat" cmpd="sng" algn="ctr">
+                      <a:solidFill>
+                        <a:srgbClr val="DBE3EA"/>
+                      </a:solidFill>
+                      <a:prstDash val="solid"/>
+                      <a:round/>
+                      <a:headEnd type="none" w="med" len="med"/>
+                      <a:tailEnd type="none" w="med" len="med"/>
+                    </a:lnT>
+                    <a:lnB w="12700" cap="flat" cmpd="sng" algn="ctr">
+                      <a:solidFill>
+                        <a:srgbClr val="DBE3EA"/>
+                      </a:solidFill>
+                      <a:prstDash val="solid"/>
+                      <a:round/>
+                      <a:headEnd type="none" w="med" len="med"/>
+                      <a:tailEnd type="none" w="med" len="med"/>
+                    </a:lnB>
+                  </a:tcPr>
+                </a:tc>
+              </a:tr>
+              <a:tr h="402336">
+                <a:tc>
+                  <a:txBody>
+                    <a:bodyPr/>
+                    <a:lstStyle/>
+                    <a:p>
+                      <a:pPr algn="l" indent="0" marL="0">
+                        <a:buNone/>
+                      </a:pPr>
+                      <a:r>
+                        <a:rPr lang="en-US" sz="1350" dirty="0">
+                          <a:solidFill>
+                            <a:srgbClr val="1A2230"/>
+                          </a:solidFill>
+                          <a:latin typeface="Calibri" pitchFamily="34" charset="0"/>
+                          <a:ea typeface="Calibri" pitchFamily="34" charset="-122"/>
+                          <a:cs typeface="Calibri" pitchFamily="34" charset="-120"/>
+                        </a:rPr>
+                        <a:t>Permits + net-metering</a:t>
+                      </a:r>
+                      <a:endParaRPr lang="en-US" sz="1350" dirty="0">
+                        <a:latin typeface="Calibri" charset="0"/>
+                        <a:ea typeface="Calibri" charset="0"/>
+                        <a:cs typeface="Calibri" charset="0"/>
+                      </a:endParaRPr>
+                    </a:p>
+                  </a:txBody>
+                  <a:tcPr marL="76200" marR="76200" marT="38100" marB="38100" anchor="ctr">
+                    <a:lnL w="12700" cap="flat" cmpd="sng" algn="ctr">
+                      <a:solidFill>
+                        <a:srgbClr val="DBE3EA"/>
+                      </a:solidFill>
+                      <a:prstDash val="solid"/>
+                      <a:round/>
+                      <a:headEnd type="none" w="med" len="med"/>
+                      <a:tailEnd type="none" w="med" len="med"/>
+                    </a:lnL>
+                    <a:lnR w="12700" cap="flat" cmpd="sng" algn="ctr">
+                      <a:solidFill>
+                        <a:srgbClr val="DBE3EA"/>
+                      </a:solidFill>
+                      <a:prstDash val="solid"/>
+                      <a:round/>
+                      <a:headEnd type="none" w="med" len="med"/>
+                      <a:tailEnd type="none" w="med" len="med"/>
+                    </a:lnR>
+                    <a:lnT w="12700" cap="flat" cmpd="sng" algn="ctr">
+                      <a:solidFill>
+                        <a:srgbClr val="DBE3EA"/>
+                      </a:solidFill>
+                      <a:prstDash val="solid"/>
+                      <a:round/>
+                      <a:headEnd type="none" w="med" len="med"/>
+                      <a:tailEnd type="none" w="med" len="med"/>
+                    </a:lnT>
+                    <a:lnB w="12700" cap="flat" cmpd="sng" algn="ctr">
+                      <a:solidFill>
+                        <a:srgbClr val="DBE3EA"/>
+                      </a:solidFill>
+                      <a:prstDash val="solid"/>
+                      <a:round/>
+                      <a:headEnd type="none" w="med" len="med"/>
+                      <a:tailEnd type="none" w="med" len="med"/>
+                    </a:lnB>
+                  </a:tcPr>
+                </a:tc>
+                <a:tc>
+                  <a:txBody>
+                    <a:bodyPr/>
+                    <a:lstStyle/>
+                    <a:p>
+                      <a:pPr algn="r" indent="0" marL="0">
+                        <a:buNone/>
+                      </a:pPr>
+                      <a:r>
+                        <a:rPr lang="en-US" sz="1350" dirty="0">
+                          <a:solidFill>
+                            <a:srgbClr val="1A2230"/>
+                          </a:solidFill>
+                          <a:latin typeface="Calibri" pitchFamily="34" charset="0"/>
+                          <a:ea typeface="Calibri" pitchFamily="34" charset="-122"/>
+                          <a:cs typeface="Calibri" pitchFamily="34" charset="-120"/>
+                        </a:rPr>
+                        <a:t>₱6–10k</a:t>
+                      </a:r>
+                      <a:endParaRPr lang="en-US" sz="1350" dirty="0">
+                        <a:latin typeface="Calibri" charset="0"/>
+                        <a:ea typeface="Calibri" charset="0"/>
+                        <a:cs typeface="Calibri" charset="0"/>
+                      </a:endParaRPr>
+                    </a:p>
+                  </a:txBody>
+                  <a:tcPr marL="76200" marR="76200" marT="38100" marB="38100" anchor="ctr">
+                    <a:lnL w="12700" cap="flat" cmpd="sng" algn="ctr">
+                      <a:solidFill>
+                        <a:srgbClr val="DBE3EA"/>
+                      </a:solidFill>
+                      <a:prstDash val="solid"/>
+                      <a:round/>
+                      <a:headEnd type="none" w="med" len="med"/>
+                      <a:tailEnd type="none" w="med" len="med"/>
+                    </a:lnL>
+                    <a:lnR w="12700" cap="flat" cmpd="sng" algn="ctr">
+                      <a:solidFill>
+                        <a:srgbClr val="DBE3EA"/>
+                      </a:solidFill>
+                      <a:prstDash val="solid"/>
+                      <a:round/>
+                      <a:headEnd type="none" w="med" len="med"/>
+                      <a:tailEnd type="none" w="med" len="med"/>
+                    </a:lnR>
+                    <a:lnT w="12700" cap="flat" cmpd="sng" algn="ctr">
+                      <a:solidFill>
+                        <a:srgbClr val="DBE3EA"/>
+                      </a:solidFill>
+                      <a:prstDash val="solid"/>
+                      <a:round/>
+                      <a:headEnd type="none" w="med" len="med"/>
+                      <a:tailEnd type="none" w="med" len="med"/>
+                    </a:lnT>
+                    <a:lnB w="12700" cap="flat" cmpd="sng" algn="ctr">
+                      <a:solidFill>
+                        <a:srgbClr val="DBE3EA"/>
+                      </a:solidFill>
+                      <a:prstDash val="solid"/>
+                      <a:round/>
+                      <a:headEnd type="none" w="med" len="med"/>
+                      <a:tailEnd type="none" w="med" len="med"/>
+                    </a:lnB>
+                  </a:tcPr>
+                </a:tc>
+                <a:tc>
+                  <a:txBody>
+                    <a:bodyPr/>
+                    <a:lstStyle/>
+                    <a:p>
+                      <a:pPr algn="r" indent="0" marL="0">
+                        <a:buNone/>
+                      </a:pPr>
+                      <a:r>
+                        <a:rPr lang="en-US" sz="1350" dirty="0">
+                          <a:solidFill>
+                            <a:srgbClr val="1A2230"/>
+                          </a:solidFill>
+                          <a:latin typeface="Calibri" pitchFamily="34" charset="0"/>
+                          <a:ea typeface="Calibri" pitchFamily="34" charset="-122"/>
+                          <a:cs typeface="Calibri" pitchFamily="34" charset="-120"/>
+                        </a:rPr>
+                        <a:t>₱2–4k</a:t>
+                      </a:r>
+                      <a:endParaRPr lang="en-US" sz="1350" dirty="0">
+                        <a:latin typeface="Calibri" charset="0"/>
+                        <a:ea typeface="Calibri" charset="0"/>
+                        <a:cs typeface="Calibri" charset="0"/>
+                      </a:endParaRPr>
+                    </a:p>
+                  </a:txBody>
+                  <a:tcPr marL="76200" marR="76200" marT="38100" marB="38100" anchor="ctr">
+                    <a:lnL w="12700" cap="flat" cmpd="sng" algn="ctr">
+                      <a:solidFill>
+                        <a:srgbClr val="DBE3EA"/>
+                      </a:solidFill>
+                      <a:prstDash val="solid"/>
+                      <a:round/>
+                      <a:headEnd type="none" w="med" len="med"/>
+                      <a:tailEnd type="none" w="med" len="med"/>
+                    </a:lnL>
+                    <a:lnR w="12700" cap="flat" cmpd="sng" algn="ctr">
+                      <a:solidFill>
+                        <a:srgbClr val="DBE3EA"/>
+                      </a:solidFill>
+                      <a:prstDash val="solid"/>
+                      <a:round/>
+                      <a:headEnd type="none" w="med" len="med"/>
+                      <a:tailEnd type="none" w="med" len="med"/>
+                    </a:lnR>
+                    <a:lnT w="12700" cap="flat" cmpd="sng" algn="ctr">
+                      <a:solidFill>
+                        <a:srgbClr val="DBE3EA"/>
+                      </a:solidFill>
+                      <a:prstDash val="solid"/>
+                      <a:round/>
+                      <a:headEnd type="none" w="med" len="med"/>
+                      <a:tailEnd type="none" w="med" len="med"/>
+                    </a:lnT>
+                    <a:lnB w="12700" cap="flat" cmpd="sng" algn="ctr">
+                      <a:solidFill>
+                        <a:srgbClr val="DBE3EA"/>
+                      </a:solidFill>
+                      <a:prstDash val="solid"/>
+                      <a:round/>
+                      <a:headEnd type="none" w="med" len="med"/>
+                      <a:tailEnd type="none" w="med" len="med"/>
+                    </a:lnB>
+                  </a:tcPr>
+                </a:tc>
+              </a:tr>
+              <a:tr h="402336">
+                <a:tc>
+                  <a:txBody>
+                    <a:bodyPr/>
+                    <a:lstStyle/>
+                    <a:p>
+                      <a:pPr algn="l" indent="0" marL="0">
+                        <a:buNone/>
+                      </a:pPr>
+                      <a:r>
+                        <a:rPr lang="en-US" sz="1350" b="1" dirty="0">
+                          <a:solidFill>
+                            <a:srgbClr val="1A2230"/>
+                          </a:solidFill>
+                          <a:latin typeface="Calibri" pitchFamily="34" charset="0"/>
+                          <a:ea typeface="Calibri" pitchFamily="34" charset="-122"/>
+                          <a:cs typeface="Calibri" pitchFamily="34" charset="-120"/>
+                        </a:rPr>
+                        <a:t>Total cost</a:t>
+                      </a:r>
+                      <a:endParaRPr lang="en-US" sz="1350" dirty="0">
+                        <a:latin typeface="Calibri" charset="0"/>
+                        <a:ea typeface="Calibri" charset="0"/>
+                        <a:cs typeface="Calibri" charset="0"/>
+                      </a:endParaRPr>
+                    </a:p>
+                  </a:txBody>
+                  <a:tcPr marL="76200" marR="76200" marT="38100" marB="38100" anchor="ctr">
+                    <a:lnL w="12700" cap="flat" cmpd="sng" algn="ctr">
+                      <a:solidFill>
+                        <a:srgbClr val="DBE3EA"/>
+                      </a:solidFill>
+                      <a:prstDash val="solid"/>
+                      <a:round/>
+                      <a:headEnd type="none" w="med" len="med"/>
+                      <a:tailEnd type="none" w="med" len="med"/>
+                    </a:lnL>
+                    <a:lnR w="12700" cap="flat" cmpd="sng" algn="ctr">
+                      <a:solidFill>
+                        <a:srgbClr val="DBE3EA"/>
+                      </a:solidFill>
+                      <a:prstDash val="solid"/>
+                      <a:round/>
+                      <a:headEnd type="none" w="med" len="med"/>
+                      <a:tailEnd type="none" w="med" len="med"/>
+                    </a:lnR>
+                    <a:lnT w="12700" cap="flat" cmpd="sng" algn="ctr">
+                      <a:solidFill>
+                        <a:srgbClr val="DBE3EA"/>
+                      </a:solidFill>
+                      <a:prstDash val="solid"/>
+                      <a:round/>
+                      <a:headEnd type="none" w="med" len="med"/>
+                      <a:tailEnd type="none" w="med" len="med"/>
+                    </a:lnT>
+                    <a:lnB w="12700" cap="flat" cmpd="sng" algn="ctr">
+                      <a:solidFill>
+                        <a:srgbClr val="DBE3EA"/>
+                      </a:solidFill>
+                      <a:prstDash val="solid"/>
+                      <a:round/>
+                      <a:headEnd type="none" w="med" len="med"/>
+                      <a:tailEnd type="none" w="med" len="med"/>
+                    </a:lnB>
+                    <a:solidFill>
+                      <a:srgbClr val="E7EDF2"/>
+                    </a:solidFill>
+                  </a:tcPr>
+                </a:tc>
+                <a:tc>
+                  <a:txBody>
+                    <a:bodyPr/>
+                    <a:lstStyle/>
+                    <a:p>
+                      <a:pPr algn="r" indent="0" marL="0">
+                        <a:buNone/>
+                      </a:pPr>
+                      <a:r>
+                        <a:rPr lang="en-US" sz="1350" b="1" dirty="0">
+                          <a:solidFill>
+                            <a:srgbClr val="1A2230"/>
+                          </a:solidFill>
+                          <a:latin typeface="Calibri" pitchFamily="34" charset="0"/>
+                          <a:ea typeface="Calibri" pitchFamily="34" charset="-122"/>
+                          <a:cs typeface="Calibri" pitchFamily="34" charset="-120"/>
+                        </a:rPr>
+                        <a:t>₱62–86k</a:t>
+                      </a:r>
+                      <a:endParaRPr lang="en-US" sz="1350" dirty="0">
+                        <a:latin typeface="Calibri" charset="0"/>
+                        <a:ea typeface="Calibri" charset="0"/>
+                        <a:cs typeface="Calibri" charset="0"/>
+                      </a:endParaRPr>
+                    </a:p>
+                  </a:txBody>
+                  <a:tcPr marL="76200" marR="76200" marT="38100" marB="38100" anchor="ctr">
+                    <a:lnL w="12700" cap="flat" cmpd="sng" algn="ctr">
+                      <a:solidFill>
+                        <a:srgbClr val="DBE3EA"/>
+                      </a:solidFill>
+                      <a:prstDash val="solid"/>
+                      <a:round/>
+                      <a:headEnd type="none" w="med" len="med"/>
+                      <a:tailEnd type="none" w="med" len="med"/>
+                    </a:lnL>
+                    <a:lnR w="12700" cap="flat" cmpd="sng" algn="ctr">
+                      <a:solidFill>
+                        <a:srgbClr val="DBE3EA"/>
+                      </a:solidFill>
+                      <a:prstDash val="solid"/>
+                      <a:round/>
+                      <a:headEnd type="none" w="med" len="med"/>
+                      <a:tailEnd type="none" w="med" len="med"/>
+                    </a:lnR>
+                    <a:lnT w="12700" cap="flat" cmpd="sng" algn="ctr">
+                      <a:solidFill>
+                        <a:srgbClr val="DBE3EA"/>
+                      </a:solidFill>
+                      <a:prstDash val="solid"/>
+                      <a:round/>
+                      <a:headEnd type="none" w="med" len="med"/>
+                      <a:tailEnd type="none" w="med" len="med"/>
+                    </a:lnT>
+                    <a:lnB w="12700" cap="flat" cmpd="sng" algn="ctr">
+                      <a:solidFill>
+                        <a:srgbClr val="DBE3EA"/>
+                      </a:solidFill>
+                      <a:prstDash val="solid"/>
+                      <a:round/>
+                      <a:headEnd type="none" w="med" len="med"/>
+                      <a:tailEnd type="none" w="med" len="med"/>
+                    </a:lnB>
+                    <a:solidFill>
+                      <a:srgbClr val="E7EDF2"/>
+                    </a:solidFill>
+                  </a:tcPr>
+                </a:tc>
+                <a:tc>
+                  <a:txBody>
+                    <a:bodyPr/>
+                    <a:lstStyle/>
+                    <a:p>
+                      <a:pPr algn="r" indent="0" marL="0">
+                        <a:buNone/>
+                      </a:pPr>
+                      <a:r>
+                        <a:rPr lang="en-US" sz="1350" b="1" dirty="0">
+                          <a:solidFill>
+                            <a:srgbClr val="1A2230"/>
+                          </a:solidFill>
+                          <a:latin typeface="Calibri" pitchFamily="34" charset="0"/>
+                          <a:ea typeface="Calibri" pitchFamily="34" charset="-122"/>
+                          <a:cs typeface="Calibri" pitchFamily="34" charset="-120"/>
+                        </a:rPr>
+                        <a:t>₱73–104k</a:t>
+                      </a:r>
+                      <a:endParaRPr lang="en-US" sz="1350" dirty="0">
+                        <a:latin typeface="Calibri" charset="0"/>
+                        <a:ea typeface="Calibri" charset="0"/>
+                        <a:cs typeface="Calibri" charset="0"/>
+                      </a:endParaRPr>
+                    </a:p>
+                  </a:txBody>
+                  <a:tcPr marL="76200" marR="76200" marT="38100" marB="38100" anchor="ctr">
+                    <a:lnL w="12700" cap="flat" cmpd="sng" algn="ctr">
+                      <a:solidFill>
+                        <a:srgbClr val="DBE3EA"/>
+                      </a:solidFill>
+                      <a:prstDash val="solid"/>
+                      <a:round/>
+                      <a:headEnd type="none" w="med" len="med"/>
+                      <a:tailEnd type="none" w="med" len="med"/>
+                    </a:lnL>
+                    <a:lnR w="12700" cap="flat" cmpd="sng" algn="ctr">
+                      <a:solidFill>
+                        <a:srgbClr val="DBE3EA"/>
+                      </a:solidFill>
+                      <a:prstDash val="solid"/>
+                      <a:round/>
+                      <a:headEnd type="none" w="med" len="med"/>
+                      <a:tailEnd type="none" w="med" len="med"/>
+                    </a:lnR>
+                    <a:lnT w="12700" cap="flat" cmpd="sng" algn="ctr">
+                      <a:solidFill>
+                        <a:srgbClr val="DBE3EA"/>
+                      </a:solidFill>
+                      <a:prstDash val="solid"/>
+                      <a:round/>
+                      <a:headEnd type="none" w="med" len="med"/>
+                      <a:tailEnd type="none" w="med" len="med"/>
+                    </a:lnT>
+                    <a:lnB w="12700" cap="flat" cmpd="sng" algn="ctr">
+                      <a:solidFill>
+                        <a:srgbClr val="DBE3EA"/>
+                      </a:solidFill>
+                      <a:prstDash val="solid"/>
+                      <a:round/>
+                      <a:headEnd type="none" w="med" len="med"/>
+                      <a:tailEnd type="none" w="med" len="med"/>
+                    </a:lnB>
+                    <a:solidFill>
+                      <a:srgbClr val="E7EDF2"/>
+                    </a:solidFill>
+                  </a:tcPr>
+                </a:tc>
+              </a:tr>
+              <a:tr h="402336">
+                <a:tc>
+                  <a:txBody>
+                    <a:bodyPr/>
+                    <a:lstStyle/>
+                    <a:p>
+                      <a:pPr algn="l" indent="0" marL="0">
+                        <a:buNone/>
+                      </a:pPr>
+                      <a:r>
+                        <a:rPr lang="en-US" sz="1350" b="1" dirty="0">
+                          <a:solidFill>
+                            <a:srgbClr val="1A2230"/>
+                          </a:solidFill>
+                          <a:latin typeface="Calibri" pitchFamily="34" charset="0"/>
+                          <a:ea typeface="Calibri" pitchFamily="34" charset="-122"/>
+                          <a:cs typeface="Calibri" pitchFamily="34" charset="-120"/>
+                        </a:rPr>
+                        <a:t>Gross margin @ ₱99.5k</a:t>
+                      </a:r>
+                      <a:endParaRPr lang="en-US" sz="1350" dirty="0">
+                        <a:latin typeface="Calibri" charset="0"/>
+                        <a:ea typeface="Calibri" charset="0"/>
+                        <a:cs typeface="Calibri" charset="0"/>
+                      </a:endParaRPr>
+                    </a:p>
+                  </a:txBody>
+                  <a:tcPr marL="76200" marR="76200" marT="38100" marB="38100" anchor="ctr">
+                    <a:lnL w="12700" cap="flat" cmpd="sng" algn="ctr">
+                      <a:solidFill>
+                        <a:srgbClr val="DBE3EA"/>
+                      </a:solidFill>
+                      <a:prstDash val="solid"/>
+                      <a:round/>
+                      <a:headEnd type="none" w="med" len="med"/>
+                      <a:tailEnd type="none" w="med" len="med"/>
+                    </a:lnL>
+                    <a:lnR w="12700" cap="flat" cmpd="sng" algn="ctr">
+                      <a:solidFill>
+                        <a:srgbClr val="DBE3EA"/>
+                      </a:solidFill>
+                      <a:prstDash val="solid"/>
+                      <a:round/>
+                      <a:headEnd type="none" w="med" len="med"/>
+                      <a:tailEnd type="none" w="med" len="med"/>
+                    </a:lnR>
+                    <a:lnT w="12700" cap="flat" cmpd="sng" algn="ctr">
+                      <a:solidFill>
+                        <a:srgbClr val="DBE3EA"/>
+                      </a:solidFill>
+                      <a:prstDash val="solid"/>
+                      <a:round/>
+                      <a:headEnd type="none" w="med" len="med"/>
+                      <a:tailEnd type="none" w="med" len="med"/>
+                    </a:lnT>
+                    <a:lnB w="12700" cap="flat" cmpd="sng" algn="ctr">
+                      <a:solidFill>
+                        <a:srgbClr val="DBE3EA"/>
+                      </a:solidFill>
+                      <a:prstDash val="solid"/>
+                      <a:round/>
+                      <a:headEnd type="none" w="med" len="med"/>
+                      <a:tailEnd type="none" w="med" len="med"/>
+                    </a:lnB>
+                    <a:solidFill>
+                      <a:srgbClr val="FBEFC9"/>
+                    </a:solidFill>
+                  </a:tcPr>
+                </a:tc>
+                <a:tc>
+                  <a:txBody>
+                    <a:bodyPr/>
+                    <a:lstStyle/>
+                    <a:p>
+                      <a:pPr algn="r" indent="0" marL="0">
+                        <a:buNone/>
+                      </a:pPr>
+                      <a:r>
+                        <a:rPr lang="en-US" sz="1350" b="1" dirty="0">
+                          <a:solidFill>
+                            <a:srgbClr val="1A2230"/>
+                          </a:solidFill>
+                          <a:latin typeface="Calibri" pitchFamily="34" charset="0"/>
+                          <a:ea typeface="Calibri" pitchFamily="34" charset="-122"/>
+                          <a:cs typeface="Calibri" pitchFamily="34" charset="-120"/>
+                        </a:rPr>
+                        <a:t>₱14–38k (14–38%)</a:t>
+                      </a:r>
+                      <a:endParaRPr lang="en-US" sz="1350" dirty="0">
+                        <a:latin typeface="Calibri" charset="0"/>
+                        <a:ea typeface="Calibri" charset="0"/>
+                        <a:cs typeface="Calibri" charset="0"/>
+                      </a:endParaRPr>
+                    </a:p>
+                  </a:txBody>
+                  <a:tcPr marL="76200" marR="76200" marT="38100" marB="38100" anchor="ctr">
+                    <a:lnL w="12700" cap="flat" cmpd="sng" algn="ctr">
+                      <a:solidFill>
+                        <a:srgbClr val="DBE3EA"/>
+                      </a:solidFill>
+                      <a:prstDash val="solid"/>
+                      <a:round/>
+                      <a:headEnd type="none" w="med" len="med"/>
+                      <a:tailEnd type="none" w="med" len="med"/>
+                    </a:lnL>
+                    <a:lnR w="12700" cap="flat" cmpd="sng" algn="ctr">
+                      <a:solidFill>
+                        <a:srgbClr val="DBE3EA"/>
+                      </a:solidFill>
+                      <a:prstDash val="solid"/>
+                      <a:round/>
+                      <a:headEnd type="none" w="med" len="med"/>
+                      <a:tailEnd type="none" w="med" len="med"/>
+                    </a:lnR>
+                    <a:lnT w="12700" cap="flat" cmpd="sng" algn="ctr">
+                      <a:solidFill>
+                        <a:srgbClr val="DBE3EA"/>
+                      </a:solidFill>
+                      <a:prstDash val="solid"/>
+                      <a:round/>
+                      <a:headEnd type="none" w="med" len="med"/>
+                      <a:tailEnd type="none" w="med" len="med"/>
+                    </a:lnT>
+                    <a:lnB w="12700" cap="flat" cmpd="sng" algn="ctr">
+                      <a:solidFill>
+                        <a:srgbClr val="DBE3EA"/>
+                      </a:solidFill>
+                      <a:prstDash val="solid"/>
+                      <a:round/>
+                      <a:headEnd type="none" w="med" len="med"/>
+                      <a:tailEnd type="none" w="med" len="med"/>
+                    </a:lnB>
+                    <a:solidFill>
+                      <a:srgbClr val="FBEFC9"/>
+                    </a:solidFill>
+                  </a:tcPr>
+                </a:tc>
+                <a:tc>
+                  <a:txBody>
+                    <a:bodyPr/>
+                    <a:lstStyle/>
+                    <a:p>
+                      <a:pPr algn="r" indent="0" marL="0">
+                        <a:buNone/>
+                      </a:pPr>
+                      <a:r>
+                        <a:rPr lang="en-US" sz="1350" b="1" dirty="0">
+                          <a:solidFill>
+                            <a:srgbClr val="1A2230"/>
+                          </a:solidFill>
+                          <a:latin typeface="Calibri" pitchFamily="34" charset="0"/>
+                          <a:ea typeface="Calibri" pitchFamily="34" charset="-122"/>
+                          <a:cs typeface="Calibri" pitchFamily="34" charset="-120"/>
+                        </a:rPr>
+                        <a:t>−₱5k → ₱27k</a:t>
+                      </a:r>
+                      <a:endParaRPr lang="en-US" sz="1350" dirty="0">
+                        <a:latin typeface="Calibri" charset="0"/>
+                        <a:ea typeface="Calibri" charset="0"/>
+                        <a:cs typeface="Calibri" charset="0"/>
+                      </a:endParaRPr>
+                    </a:p>
+                  </a:txBody>
+                  <a:tcPr marL="76200" marR="76200" marT="38100" marB="38100" anchor="ctr">
+                    <a:lnL w="12700" cap="flat" cmpd="sng" algn="ctr">
+                      <a:solidFill>
+                        <a:srgbClr val="DBE3EA"/>
+                      </a:solidFill>
+                      <a:prstDash val="solid"/>
+                      <a:round/>
+                      <a:headEnd type="none" w="med" len="med"/>
+                      <a:tailEnd type="none" w="med" len="med"/>
+                    </a:lnL>
+                    <a:lnR w="12700" cap="flat" cmpd="sng" algn="ctr">
+                      <a:solidFill>
+                        <a:srgbClr val="DBE3EA"/>
+                      </a:solidFill>
+                      <a:prstDash val="solid"/>
+                      <a:round/>
+                      <a:headEnd type="none" w="med" len="med"/>
+                      <a:tailEnd type="none" w="med" len="med"/>
+                    </a:lnR>
+                    <a:lnT w="12700" cap="flat" cmpd="sng" algn="ctr">
+                      <a:solidFill>
+                        <a:srgbClr val="DBE3EA"/>
+                      </a:solidFill>
+                      <a:prstDash val="solid"/>
+                      <a:round/>
+                      <a:headEnd type="none" w="med" len="med"/>
+                      <a:tailEnd type="none" w="med" len="med"/>
+                    </a:lnT>
+                    <a:lnB w="12700" cap="flat" cmpd="sng" algn="ctr">
+                      <a:solidFill>
+                        <a:srgbClr val="DBE3EA"/>
+                      </a:solidFill>
+                      <a:prstDash val="solid"/>
+                      <a:round/>
+                      <a:headEnd type="none" w="med" len="med"/>
+                      <a:tailEnd type="none" w="med" len="med"/>
+                    </a:lnB>
+                    <a:solidFill>
+                      <a:srgbClr val="FBEFC9"/>
+                    </a:solidFill>
+                  </a:tcPr>
+                </a:tc>
+              </a:tr>
+            </a:tbl>
+          </a:graphicData>
+        </a:graphic>
+      </p:graphicFrame>
+      <p:sp>
+        <p:nvSpPr>
+          <p:cNvPr id="5" name="Shape 2"/>
+          <p:cNvSpPr/>
+          <p:nvPr/>
+        </p:nvSpPr>
+        <p:spPr>
+          <a:xfrm>
+            <a:off x="8458200" y="1600200"/>
+            <a:ext cx="3154680" cy="4160520"/>
+          </a:xfrm>
+          <a:prstGeom prst="roundRect">
+            <a:avLst>
+              <a:gd name="adj" fmla="val 2609"/>
+            </a:avLst>
+          </a:prstGeom>
+          <a:solidFill>
+            <a:srgbClr val="12233A"/>
+          </a:solidFill>
+          <a:ln w="12700">
+            <a:solidFill>
+              <a:srgbClr val="DBE3EA"/>
+            </a:solidFill>
+            <a:prstDash val="solid"/>
+          </a:ln>
+          <a:effectLst>
+            <a:outerShdw sx="100000" sy="100000" kx="0" ky="0" algn="bl" rotWithShape="0" blurRad="88900" dist="25400" dir="5400000">
+              <a:srgbClr val="9AA7B4">
+                <a:alpha val="35000"/>
+              </a:srgbClr>
+            </a:outerShdw>
+          </a:effectLst>
+        </p:spPr>
+      </p:sp>
+      <p:sp>
+        <p:nvSpPr>
+          <p:cNvPr id="6" name="Text 3"/>
+          <p:cNvSpPr/>
+          <p:nvPr/>
+        </p:nvSpPr>
+        <p:spPr>
+          <a:xfrm>
+            <a:off x="8732520" y="1828800"/>
+            <a:ext cx="2651760" cy="365760"/>
+          </a:xfrm>
+          <a:prstGeom prst="rect">
+            <a:avLst/>
+          </a:prstGeom>
+          <a:noFill/>
+          <a:ln/>
+        </p:spPr>
+        <p:txBody>
+          <a:bodyPr wrap="square" lIns="0" tIns="0" rIns="0" bIns="0" rtlCol="0" anchor="ctr"/>
+          <a:lstStyle/>
+          <a:p>
+            <a:pPr indent="0" marL="0">
+              <a:buNone/>
+            </a:pPr>
+            <a:r>
+              <a:rPr lang="en-US" sz="1200" b="1" spc="200" kern="0" dirty="0">
+                <a:solidFill>
+                  <a:srgbClr val="F2B705"/>
+                </a:solidFill>
+                <a:latin typeface="Calibri" pitchFamily="34" charset="0"/>
+                <a:ea typeface="Calibri" pitchFamily="34" charset="-122"/>
+                <a:cs typeface="Calibri" pitchFamily="34" charset="-120"/>
+              </a:rPr>
+              <a:t>Read this</a:t>
+            </a:r>
+            <a:endParaRPr lang="en-US" sz="1200" dirty="0"/>
+          </a:p>
+        </p:txBody>
+      </p:sp>
+      <p:sp>
+        <p:nvSpPr>
+          <p:cNvPr id="7" name="Text 4"/>
+          <p:cNvSpPr/>
+          <p:nvPr/>
+        </p:nvSpPr>
+        <p:spPr>
+          <a:xfrm>
+            <a:off x="8732520" y="2240280"/>
+            <a:ext cx="2651760" cy="3383280"/>
+          </a:xfrm>
+          <a:prstGeom prst="rect">
+            <a:avLst/>
+          </a:prstGeom>
+          <a:noFill/>
+          <a:ln/>
+        </p:spPr>
+        <p:txBody>
+          <a:bodyPr wrap="square" lIns="0" tIns="0" rIns="0" bIns="0" rtlCol="0" anchor="ctr"/>
+          <a:lstStyle/>
+          <a:p>
+            <a:pPr marL="177800" indent="-177800">
+              <a:lnSpc>
+                <a:spcPct val="110000"/>
+              </a:lnSpc>
+              <a:spcAft>
+                <a:spcPts val="1200"/>
+              </a:spcAft>
+              <a:buSzPct val="100000"/>
+              <a:buChar char="•"/>
+            </a:pPr>
+            <a:r>
+              <a:rPr lang="en-US" sz="1300" dirty="0">
+                <a:solidFill>
+                  <a:srgbClr val="E6EDF5"/>
+                </a:solidFill>
+                <a:latin typeface="Calibri" pitchFamily="34" charset="0"/>
+                <a:ea typeface="Calibri" pitchFamily="34" charset="-122"/>
+                <a:cs typeface="Calibri" pitchFamily="34" charset="-120"/>
+              </a:rPr>
+              <a:t>The battery tier makes or breaks the off-grid package.</a:t>
+            </a:r>
+            <a:endParaRPr lang="en-US" sz="1300" dirty="0"/>
+          </a:p>
+          <a:p>
+            <a:pPr marL="177800" indent="-177800">
+              <a:lnSpc>
+                <a:spcPct val="110000"/>
+              </a:lnSpc>
+              <a:spcAft>
+                <a:spcPts val="1200"/>
+              </a:spcAft>
+              <a:buSzPct val="100000"/>
+              <a:buChar char="•"/>
+            </a:pPr>
+            <a:r>
+              <a:rPr lang="en-US" sz="1300" dirty="0">
+                <a:solidFill>
+                  <a:srgbClr val="E6EDF5"/>
+                </a:solidFill>
+                <a:latin typeface="Calibri" pitchFamily="34" charset="0"/>
+                <a:ea typeface="Calibri" pitchFamily="34" charset="-122"/>
+                <a:cs typeface="Calibri" pitchFamily="34" charset="-120"/>
+              </a:rPr>
+              <a:t>Hold the base battery size; sell storage upgrades separately.</a:t>
+            </a:r>
+            <a:endParaRPr lang="en-US" sz="1300" dirty="0"/>
+          </a:p>
+          <a:p>
+            <a:pPr marL="177800" indent="-177800">
+              <a:lnSpc>
+                <a:spcPct val="110000"/>
+              </a:lnSpc>
+              <a:spcAft>
+                <a:spcPts val="1200"/>
+              </a:spcAft>
+              <a:buSzPct val="100000"/>
+              <a:buChar char="•"/>
+            </a:pPr>
+            <a:r>
+              <a:rPr lang="en-US" sz="1300" dirty="0">
+                <a:solidFill>
+                  <a:srgbClr val="E6EDF5"/>
+                </a:solidFill>
+                <a:latin typeface="Calibri" pitchFamily="34" charset="0"/>
+                <a:ea typeface="Calibri" pitchFamily="34" charset="-122"/>
+                <a:cs typeface="Calibri" pitchFamily="34" charset="-120"/>
+              </a:rPr>
+              <a:t>Price from the corridor, cost backward — never cost-plus.</a:t>
+            </a:r>
+            <a:endParaRPr lang="en-US" sz="1300" dirty="0"/>
+          </a:p>
+          <a:p>
+            <a:pPr marL="177800" indent="-177800">
+              <a:lnSpc>
+                <a:spcPct val="110000"/>
+              </a:lnSpc>
+              <a:spcAft>
+                <a:spcPts val="1200"/>
+              </a:spcAft>
+              <a:buSzPct val="100000"/>
+              <a:buChar char="•"/>
+            </a:pPr>
+            <a:r>
+              <a:rPr lang="en-US" sz="1300" dirty="0">
+                <a:solidFill>
+                  <a:srgbClr val="E6EDF5"/>
+                </a:solidFill>
+                <a:latin typeface="Calibri" pitchFamily="34" charset="0"/>
+                <a:ea typeface="Calibri" pitchFamily="34" charset="-122"/>
+                <a:cs typeface="Calibri" pitchFamily="34" charset="-120"/>
+              </a:rPr>
+              <a:t>Building racking + boxes moves ₱10–14k/install into our pocket.</a:t>
+            </a:r>
+            <a:endParaRPr lang="en-US" sz="1300" dirty="0"/>
+          </a:p>
+        </p:txBody>
+      </p:sp>
+      <p:sp>
+        <p:nvSpPr>
+          <p:cNvPr id="8" name="Text 5"/>
+          <p:cNvSpPr/>
+          <p:nvPr/>
+        </p:nvSpPr>
+        <p:spPr>
+          <a:xfrm>
+            <a:off x="548640" y="5989320"/>
+            <a:ext cx="10972800" cy="365760"/>
+          </a:xfrm>
+          <a:prstGeom prst="rect">
+            <a:avLst/>
+          </a:prstGeom>
+          <a:noFill/>
+          <a:ln/>
+        </p:spPr>
+        <p:txBody>
+          <a:bodyPr wrap="square" lIns="0" tIns="0" rIns="0" bIns="0" rtlCol="0" anchor="ctr"/>
+          <a:lstStyle/>
+          <a:p>
+            <a:pPr indent="0" marL="0">
+              <a:buNone/>
+            </a:pPr>
+            <a:r>
+              <a:rPr lang="en-US" sz="1100" i="1" dirty="0">
+                <a:solidFill>
+                  <a:srgbClr val="5C6B7A"/>
+                </a:solidFill>
+                <a:latin typeface="Calibri" pitchFamily="34" charset="0"/>
+                <a:ea typeface="Calibri" pitchFamily="34" charset="-122"/>
+                <a:cs typeface="Calibri" pitchFamily="34" charset="-120"/>
+              </a:rPr>
+              <a:t>Estimates dated 2026-07-19 · re-quote before pricing (SC-05 §4).</a:t>
+            </a:r>
+            <a:endParaRPr lang="en-US" sz="1100" dirty="0"/>
+          </a:p>
+        </p:txBody>
+      </p:sp>
+    </p:spTree>
+  </p:cSld>
+  <p:clrMapOvr>
+    <a:masterClrMapping/>
+  </p:clrMapOvr>
+</p:sld>
+</file>
+
+<file path=ppt/slides/slide16.xml><?xml version="1.0" encoding="utf-8"?>
+<p:sld xmlns:a="http://schemas.openxmlformats.org/drawingml/2006/main" xmlns:r="http://schemas.openxmlformats.org/officeDocument/2006/relationships" xmlns:p="http://schemas.openxmlformats.org/presentationml/2006/main">
+  <p:cSld name="Slide 16">
+    <p:bg>
+      <p:bgPr>
+        <a:solidFill>
+          <a:srgbClr val="F3F6F9"/>
+        </a:solidFill>
+      </p:bgPr>
+    </p:bg>
+    <p:spTree>
+      <p:nvGrpSpPr>
+        <p:cNvPr id="1" name=""/>
+        <p:cNvGrpSpPr/>
+        <p:nvPr/>
+      </p:nvGrpSpPr>
+      <p:grpSpPr>
+        <a:xfrm>
+          <a:off x="0" y="0"/>
+          <a:ext cx="0" cy="0"/>
+          <a:chOff x="0" y="0"/>
+          <a:chExt cx="0" cy="0"/>
+        </a:xfrm>
+      </p:grpSpPr>
+      <p:sp>
+        <p:nvSpPr>
+          <p:cNvPr id="2" name="Text 0"/>
+          <p:cNvSpPr/>
+          <p:nvPr/>
+        </p:nvSpPr>
+        <p:spPr>
+          <a:xfrm>
+            <a:off x="548640" y="256032"/>
+            <a:ext cx="11064240" cy="274320"/>
+          </a:xfrm>
+          <a:prstGeom prst="rect">
+            <a:avLst/>
+          </a:prstGeom>
+          <a:noFill/>
+          <a:ln/>
+        </p:spPr>
+        <p:txBody>
+          <a:bodyPr wrap="square" lIns="0" tIns="0" rIns="0" bIns="0" rtlCol="0" anchor="ctr"/>
+          <a:lstStyle/>
+          <a:p>
+            <a:pPr indent="0" marL="0">
+              <a:buNone/>
+            </a:pPr>
+            <a:r>
+              <a:rPr lang="en-US" sz="1200" b="1" spc="200" kern="0" dirty="0">
+                <a:solidFill>
+                  <a:srgbClr val="1C7293"/>
+                </a:solidFill>
+                <a:latin typeface="Calibri" pitchFamily="34" charset="0"/>
+                <a:ea typeface="Calibri" pitchFamily="34" charset="-122"/>
+                <a:cs typeface="Calibri" pitchFamily="34" charset="-120"/>
+              </a:rPr>
+              <a:t>APPENDIX · CHANNEL TESTS</a:t>
+            </a:r>
+            <a:endParaRPr lang="en-US" sz="1200" dirty="0"/>
+          </a:p>
+        </p:txBody>
+      </p:sp>
+      <p:sp>
+        <p:nvSpPr>
+          <p:cNvPr id="3" name="Text 1"/>
+          <p:cNvSpPr/>
+          <p:nvPr/>
+        </p:nvSpPr>
+        <p:spPr>
+          <a:xfrm>
+            <a:off x="548640" y="411480"/>
+            <a:ext cx="11064240" cy="822960"/>
+          </a:xfrm>
+          <a:prstGeom prst="rect">
+            <a:avLst/>
+          </a:prstGeom>
+          <a:noFill/>
+          <a:ln/>
+        </p:spPr>
+        <p:txBody>
+          <a:bodyPr wrap="square" lIns="0" tIns="0" rIns="0" bIns="0" rtlCol="0" anchor="ctr"/>
+          <a:lstStyle/>
+          <a:p>
+            <a:pPr algn="l" indent="0" marL="0">
+              <a:buNone/>
+            </a:pPr>
+            <a:r>
+              <a:rPr lang="en-US" sz="3200" b="1" dirty="0">
+                <a:solidFill>
+                  <a:srgbClr val="1A2230"/>
+                </a:solidFill>
+                <a:latin typeface="Cambria" pitchFamily="34" charset="0"/>
+                <a:ea typeface="Cambria" pitchFamily="34" charset="-122"/>
+                <a:cs typeface="Cambria" pitchFamily="34" charset="-120"/>
+              </a:rPr>
+              <a:t>Pre-registered test scorecards</a:t>
+            </a:r>
+            <a:endParaRPr lang="en-US" sz="3200" dirty="0"/>
+          </a:p>
+        </p:txBody>
+      </p:sp>
+      <p:sp>
+        <p:nvSpPr>
+          <p:cNvPr id="4" name="Shape 2"/>
+          <p:cNvSpPr/>
+          <p:nvPr/>
+        </p:nvSpPr>
+        <p:spPr>
+          <a:xfrm>
+            <a:off x="548640" y="1645920"/>
+            <a:ext cx="5257800" cy="3520440"/>
+          </a:xfrm>
+          <a:prstGeom prst="roundRect">
+            <a:avLst>
+              <a:gd name="adj" fmla="val 2338"/>
+            </a:avLst>
+          </a:prstGeom>
+          <a:solidFill>
+            <a:srgbClr val="FFFFFF"/>
+          </a:solidFill>
+          <a:ln w="12700">
+            <a:solidFill>
+              <a:srgbClr val="DBE3EA"/>
+            </a:solidFill>
+            <a:prstDash val="solid"/>
+          </a:ln>
+          <a:effectLst>
+            <a:outerShdw sx="100000" sy="100000" kx="0" ky="0" algn="bl" rotWithShape="0" blurRad="88900" dist="25400" dir="5400000">
+              <a:srgbClr val="9AA7B4">
+                <a:alpha val="35000"/>
+              </a:srgbClr>
+            </a:outerShdw>
+          </a:effectLst>
+        </p:spPr>
+      </p:sp>
+      <p:sp>
+        <p:nvSpPr>
+          <p:cNvPr id="5" name="Text 3"/>
+          <p:cNvSpPr/>
+          <p:nvPr/>
+        </p:nvSpPr>
+        <p:spPr>
+          <a:xfrm>
+            <a:off x="914400" y="1874520"/>
+            <a:ext cx="4572000" cy="320040"/>
+          </a:xfrm>
+          <a:prstGeom prst="rect">
+            <a:avLst/>
+          </a:prstGeom>
+          <a:noFill/>
+          <a:ln/>
+        </p:spPr>
+        <p:txBody>
+          <a:bodyPr wrap="square" lIns="0" tIns="0" rIns="0" bIns="0" rtlCol="0" anchor="ctr"/>
+          <a:lstStyle/>
+          <a:p>
+            <a:pPr indent="0" marL="0">
+              <a:buNone/>
+            </a:pPr>
+            <a:r>
+              <a:rPr lang="en-US" sz="1200" b="1" spc="100" kern="0" dirty="0">
+                <a:solidFill>
+                  <a:srgbClr val="1C7293"/>
+                </a:solidFill>
+                <a:latin typeface="Calibri" pitchFamily="34" charset="0"/>
+                <a:ea typeface="Calibri" pitchFamily="34" charset="-122"/>
+                <a:cs typeface="Calibri" pitchFamily="34" charset="-120"/>
+              </a:rPr>
+              <a:t>TEST 1</a:t>
+            </a:r>
+            <a:endParaRPr lang="en-US" sz="1200" dirty="0"/>
+          </a:p>
+        </p:txBody>
+      </p:sp>
+      <p:sp>
+        <p:nvSpPr>
+          <p:cNvPr id="6" name="Text 4"/>
+          <p:cNvSpPr/>
+          <p:nvPr/>
+        </p:nvSpPr>
+        <p:spPr>
+          <a:xfrm>
+            <a:off x="914400" y="2194560"/>
+            <a:ext cx="4572000" cy="502920"/>
+          </a:xfrm>
+          <a:prstGeom prst="rect">
+            <a:avLst/>
+          </a:prstGeom>
+          <a:noFill/>
+          <a:ln/>
+        </p:spPr>
+        <p:txBody>
+          <a:bodyPr wrap="square" lIns="0" tIns="0" rIns="0" bIns="0" rtlCol="0" anchor="ctr"/>
+          <a:lstStyle/>
+          <a:p>
+            <a:pPr indent="0" marL="0">
+              <a:buNone/>
+            </a:pPr>
+            <a:r>
+              <a:rPr lang="en-US" sz="1900" b="1" dirty="0">
+                <a:solidFill>
+                  <a:srgbClr val="1A2230"/>
+                </a:solidFill>
+                <a:latin typeface="Cambria" pitchFamily="34" charset="0"/>
+                <a:ea typeface="Cambria" pitchFamily="34" charset="-122"/>
+                <a:cs typeface="Cambria" pitchFamily="34" charset="-120"/>
+              </a:rPr>
+              <a:t>FB / Messenger lead ad</a:t>
+            </a:r>
+            <a:endParaRPr lang="en-US" sz="1900" dirty="0"/>
+          </a:p>
+        </p:txBody>
+      </p:sp>
+      <p:sp>
+        <p:nvSpPr>
+          <p:cNvPr id="7" name="Text 5"/>
+          <p:cNvSpPr/>
+          <p:nvPr/>
+        </p:nvSpPr>
+        <p:spPr>
+          <a:xfrm>
+            <a:off x="914400" y="2788920"/>
+            <a:ext cx="1737360" cy="384048"/>
+          </a:xfrm>
+          <a:prstGeom prst="rect">
+            <a:avLst/>
+          </a:prstGeom>
+          <a:noFill/>
+          <a:ln/>
+        </p:spPr>
+        <p:txBody>
+          <a:bodyPr wrap="square" lIns="0" tIns="0" rIns="0" bIns="0" rtlCol="0" anchor="ctr"/>
+          <a:lstStyle/>
+          <a:p>
+            <a:pPr indent="0" marL="0">
+              <a:buNone/>
+            </a:pPr>
+            <a:r>
+              <a:rPr lang="en-US" sz="1250" b="1" dirty="0">
+                <a:solidFill>
+                  <a:srgbClr val="5C6B7A"/>
+                </a:solidFill>
+                <a:latin typeface="Calibri" pitchFamily="34" charset="0"/>
+                <a:ea typeface="Calibri" pitchFamily="34" charset="-122"/>
+                <a:cs typeface="Calibri" pitchFamily="34" charset="-120"/>
+              </a:rPr>
+              <a:t>Hypothesis</a:t>
+            </a:r>
+            <a:endParaRPr lang="en-US" sz="1250" dirty="0"/>
+          </a:p>
+        </p:txBody>
+      </p:sp>
+      <p:sp>
+        <p:nvSpPr>
+          <p:cNvPr id="8" name="Text 6"/>
+          <p:cNvSpPr/>
+          <p:nvPr/>
+        </p:nvSpPr>
+        <p:spPr>
+          <a:xfrm>
+            <a:off x="2606040" y="2788920"/>
+            <a:ext cx="2880360" cy="384048"/>
+          </a:xfrm>
+          <a:prstGeom prst="rect">
+            <a:avLst/>
+          </a:prstGeom>
+          <a:noFill/>
+          <a:ln/>
+        </p:spPr>
+        <p:txBody>
+          <a:bodyPr wrap="square" lIns="0" tIns="0" rIns="0" bIns="0" rtlCol="0" anchor="ctr"/>
+          <a:lstStyle/>
+          <a:p>
+            <a:pPr indent="0" marL="0">
+              <a:buNone/>
+            </a:pPr>
+            <a:r>
+              <a:rPr lang="en-US" sz="1250" dirty="0">
+                <a:solidFill>
+                  <a:srgbClr val="1A2230"/>
+                </a:solidFill>
+                <a:latin typeface="Calibri" pitchFamily="34" charset="0"/>
+                <a:ea typeface="Calibri" pitchFamily="34" charset="-122"/>
+                <a:cs typeface="Calibri" pitchFamily="34" charset="-120"/>
+              </a:rPr>
+              <a:t>≥X% of a Naval slice submit a lead</a:t>
+            </a:r>
+            <a:endParaRPr lang="en-US" sz="1250" dirty="0"/>
+          </a:p>
+        </p:txBody>
+      </p:sp>
+      <p:sp>
+        <p:nvSpPr>
+          <p:cNvPr id="9" name="Text 7"/>
+          <p:cNvSpPr/>
+          <p:nvPr/>
+        </p:nvSpPr>
+        <p:spPr>
+          <a:xfrm>
+            <a:off x="914400" y="3246120"/>
+            <a:ext cx="1737360" cy="384048"/>
+          </a:xfrm>
+          <a:prstGeom prst="rect">
+            <a:avLst/>
+          </a:prstGeom>
+          <a:noFill/>
+          <a:ln/>
+        </p:spPr>
+        <p:txBody>
+          <a:bodyPr wrap="square" lIns="0" tIns="0" rIns="0" bIns="0" rtlCol="0" anchor="ctr"/>
+          <a:lstStyle/>
+          <a:p>
+            <a:pPr indent="0" marL="0">
+              <a:buNone/>
+            </a:pPr>
+            <a:r>
+              <a:rPr lang="en-US" sz="1250" b="1" dirty="0">
+                <a:solidFill>
+                  <a:srgbClr val="5C6B7A"/>
+                </a:solidFill>
+                <a:latin typeface="Calibri" pitchFamily="34" charset="0"/>
+                <a:ea typeface="Calibri" pitchFamily="34" charset="-122"/>
+                <a:cs typeface="Calibri" pitchFamily="34" charset="-120"/>
+              </a:rPr>
+              <a:t>Pass bar</a:t>
+            </a:r>
+            <a:endParaRPr lang="en-US" sz="1250" dirty="0"/>
+          </a:p>
+        </p:txBody>
+      </p:sp>
+      <p:sp>
+        <p:nvSpPr>
+          <p:cNvPr id="10" name="Text 8"/>
+          <p:cNvSpPr/>
+          <p:nvPr/>
+        </p:nvSpPr>
+        <p:spPr>
+          <a:xfrm>
+            <a:off x="2606040" y="3246120"/>
+            <a:ext cx="2880360" cy="384048"/>
+          </a:xfrm>
+          <a:prstGeom prst="rect">
+            <a:avLst/>
+          </a:prstGeom>
+          <a:noFill/>
+          <a:ln/>
+        </p:spPr>
+        <p:txBody>
+          <a:bodyPr wrap="square" lIns="0" tIns="0" rIns="0" bIns="0" rtlCol="0" anchor="ctr"/>
+          <a:lstStyle/>
+          <a:p>
+            <a:pPr indent="0" marL="0">
+              <a:buNone/>
+            </a:pPr>
+            <a:r>
+              <a:rPr lang="en-US" sz="1250" dirty="0">
+                <a:solidFill>
+                  <a:srgbClr val="1A2230"/>
+                </a:solidFill>
+                <a:latin typeface="Calibri" pitchFamily="34" charset="0"/>
+                <a:ea typeface="Calibri" pitchFamily="34" charset="-122"/>
+                <a:cs typeface="Calibri" pitchFamily="34" charset="-120"/>
+              </a:rPr>
+              <a:t>≤ ₱500 per qualified lead</a:t>
+            </a:r>
+            <a:endParaRPr lang="en-US" sz="1250" dirty="0"/>
+          </a:p>
+        </p:txBody>
+      </p:sp>
+      <p:sp>
+        <p:nvSpPr>
+          <p:cNvPr id="11" name="Text 9"/>
+          <p:cNvSpPr/>
+          <p:nvPr/>
+        </p:nvSpPr>
+        <p:spPr>
+          <a:xfrm>
+            <a:off x="914400" y="3703320"/>
+            <a:ext cx="1737360" cy="384048"/>
+          </a:xfrm>
+          <a:prstGeom prst="rect">
+            <a:avLst/>
+          </a:prstGeom>
+          <a:noFill/>
+          <a:ln/>
+        </p:spPr>
+        <p:txBody>
+          <a:bodyPr wrap="square" lIns="0" tIns="0" rIns="0" bIns="0" rtlCol="0" anchor="ctr"/>
+          <a:lstStyle/>
+          <a:p>
+            <a:pPr indent="0" marL="0">
+              <a:buNone/>
+            </a:pPr>
+            <a:r>
+              <a:rPr lang="en-US" sz="1250" b="1" dirty="0">
+                <a:solidFill>
+                  <a:srgbClr val="5C6B7A"/>
+                </a:solidFill>
+                <a:latin typeface="Calibri" pitchFamily="34" charset="0"/>
+                <a:ea typeface="Calibri" pitchFamily="34" charset="-122"/>
+                <a:cs typeface="Calibri" pitchFamily="34" charset="-120"/>
+              </a:rPr>
+              <a:t>Budget</a:t>
+            </a:r>
+            <a:endParaRPr lang="en-US" sz="1250" dirty="0"/>
+          </a:p>
+        </p:txBody>
+      </p:sp>
+      <p:sp>
+        <p:nvSpPr>
+          <p:cNvPr id="12" name="Text 10"/>
+          <p:cNvSpPr/>
+          <p:nvPr/>
+        </p:nvSpPr>
+        <p:spPr>
+          <a:xfrm>
+            <a:off x="2606040" y="3703320"/>
+            <a:ext cx="2880360" cy="384048"/>
+          </a:xfrm>
+          <a:prstGeom prst="rect">
+            <a:avLst/>
+          </a:prstGeom>
+          <a:noFill/>
+          <a:ln/>
+        </p:spPr>
+        <p:txBody>
+          <a:bodyPr wrap="square" lIns="0" tIns="0" rIns="0" bIns="0" rtlCol="0" anchor="ctr"/>
+          <a:lstStyle/>
+          <a:p>
+            <a:pPr indent="0" marL="0">
+              <a:buNone/>
+            </a:pPr>
+            <a:r>
+              <a:rPr lang="en-US" sz="1250" dirty="0">
+                <a:solidFill>
+                  <a:srgbClr val="1A2230"/>
+                </a:solidFill>
+                <a:latin typeface="Calibri" pitchFamily="34" charset="0"/>
+                <a:ea typeface="Calibri" pitchFamily="34" charset="-122"/>
+                <a:cs typeface="Calibri" pitchFamily="34" charset="-120"/>
+              </a:rPr>
+              <a:t>≤ ₱12k · ≤ 3 weeks</a:t>
+            </a:r>
+            <a:endParaRPr lang="en-US" sz="1250" dirty="0"/>
+          </a:p>
+        </p:txBody>
+      </p:sp>
+      <p:sp>
+        <p:nvSpPr>
+          <p:cNvPr id="13" name="Text 11"/>
+          <p:cNvSpPr/>
+          <p:nvPr/>
+        </p:nvSpPr>
+        <p:spPr>
+          <a:xfrm>
+            <a:off x="914400" y="4160520"/>
+            <a:ext cx="1737360" cy="384048"/>
+          </a:xfrm>
+          <a:prstGeom prst="rect">
+            <a:avLst/>
+          </a:prstGeom>
+          <a:noFill/>
+          <a:ln/>
+        </p:spPr>
+        <p:txBody>
+          <a:bodyPr wrap="square" lIns="0" tIns="0" rIns="0" bIns="0" rtlCol="0" anchor="ctr"/>
+          <a:lstStyle/>
+          <a:p>
+            <a:pPr indent="0" marL="0">
+              <a:buNone/>
+            </a:pPr>
+            <a:r>
+              <a:rPr lang="en-US" sz="1250" b="1" dirty="0">
+                <a:solidFill>
+                  <a:srgbClr val="5C6B7A"/>
+                </a:solidFill>
+                <a:latin typeface="Calibri" pitchFamily="34" charset="0"/>
+                <a:ea typeface="Calibri" pitchFamily="34" charset="-122"/>
+                <a:cs typeface="Calibri" pitchFamily="34" charset="-120"/>
+              </a:rPr>
+              <a:t>Precondition</a:t>
+            </a:r>
+            <a:endParaRPr lang="en-US" sz="1250" dirty="0"/>
+          </a:p>
+        </p:txBody>
+      </p:sp>
+      <p:sp>
+        <p:nvSpPr>
+          <p:cNvPr id="14" name="Text 12"/>
+          <p:cNvSpPr/>
+          <p:nvPr/>
+        </p:nvSpPr>
+        <p:spPr>
+          <a:xfrm>
+            <a:off x="2606040" y="4160520"/>
+            <a:ext cx="2880360" cy="384048"/>
+          </a:xfrm>
+          <a:prstGeom prst="rect">
+            <a:avLst/>
+          </a:prstGeom>
+          <a:noFill/>
+          <a:ln/>
+        </p:spPr>
+        <p:txBody>
+          <a:bodyPr wrap="square" lIns="0" tIns="0" rIns="0" bIns="0" rtlCol="0" anchor="ctr"/>
+          <a:lstStyle/>
+          <a:p>
+            <a:pPr indent="0" marL="0">
+              <a:buNone/>
+            </a:pPr>
+            <a:r>
+              <a:rPr lang="en-US" sz="1250" dirty="0">
+                <a:solidFill>
+                  <a:srgbClr val="1A2230"/>
+                </a:solidFill>
+                <a:latin typeface="Calibri" pitchFamily="34" charset="0"/>
+                <a:ea typeface="Calibri" pitchFamily="34" charset="-122"/>
+                <a:cs typeface="Calibri" pitchFamily="34" charset="-120"/>
+              </a:rPr>
+              <a:t>funnel + calculator live</a:t>
+            </a:r>
+            <a:endParaRPr lang="en-US" sz="1250" dirty="0"/>
+          </a:p>
+        </p:txBody>
+      </p:sp>
+      <p:sp>
+        <p:nvSpPr>
+          <p:cNvPr id="15" name="Text 13"/>
+          <p:cNvSpPr/>
+          <p:nvPr/>
+        </p:nvSpPr>
+        <p:spPr>
+          <a:xfrm>
+            <a:off x="914400" y="4617720"/>
+            <a:ext cx="1737360" cy="384048"/>
+          </a:xfrm>
+          <a:prstGeom prst="rect">
+            <a:avLst/>
+          </a:prstGeom>
+          <a:noFill/>
+          <a:ln/>
+        </p:spPr>
+        <p:txBody>
+          <a:bodyPr wrap="square" lIns="0" tIns="0" rIns="0" bIns="0" rtlCol="0" anchor="ctr"/>
+          <a:lstStyle/>
+          <a:p>
+            <a:pPr indent="0" marL="0">
+              <a:buNone/>
+            </a:pPr>
+            <a:r>
+              <a:rPr lang="en-US" sz="1250" b="1" dirty="0">
+                <a:solidFill>
+                  <a:srgbClr val="5C6B7A"/>
+                </a:solidFill>
+                <a:latin typeface="Calibri" pitchFamily="34" charset="0"/>
+                <a:ea typeface="Calibri" pitchFamily="34" charset="-122"/>
+                <a:cs typeface="Calibri" pitchFamily="34" charset="-120"/>
+              </a:rPr>
+              <a:t>Score</a:t>
+            </a:r>
+            <a:endParaRPr lang="en-US" sz="1250" dirty="0"/>
+          </a:p>
+        </p:txBody>
+      </p:sp>
+      <p:sp>
+        <p:nvSpPr>
+          <p:cNvPr id="16" name="Text 14"/>
+          <p:cNvSpPr/>
+          <p:nvPr/>
+        </p:nvSpPr>
+        <p:spPr>
+          <a:xfrm>
+            <a:off x="2606040" y="4617720"/>
+            <a:ext cx="2880360" cy="384048"/>
+          </a:xfrm>
+          <a:prstGeom prst="rect">
+            <a:avLst/>
+          </a:prstGeom>
+          <a:noFill/>
+          <a:ln/>
+        </p:spPr>
+        <p:txBody>
+          <a:bodyPr wrap="square" lIns="0" tIns="0" rIns="0" bIns="0" rtlCol="0" anchor="ctr"/>
+          <a:lstStyle/>
+          <a:p>
+            <a:pPr indent="0" marL="0">
+              <a:buNone/>
+            </a:pPr>
+            <a:r>
+              <a:rPr lang="en-US" sz="1250" dirty="0">
+                <a:solidFill>
+                  <a:srgbClr val="1A2230"/>
+                </a:solidFill>
+                <a:latin typeface="Calibri" pitchFamily="34" charset="0"/>
+                <a:ea typeface="Calibri" pitchFamily="34" charset="-122"/>
+                <a:cs typeface="Calibri" pitchFamily="34" charset="-120"/>
+              </a:rPr>
+              <a:t>pending</a:t>
+            </a:r>
+            <a:endParaRPr lang="en-US" sz="1250" dirty="0"/>
+          </a:p>
+        </p:txBody>
+      </p:sp>
+      <p:sp>
+        <p:nvSpPr>
+          <p:cNvPr id="17" name="Shape 15"/>
+          <p:cNvSpPr/>
+          <p:nvPr/>
+        </p:nvSpPr>
+        <p:spPr>
+          <a:xfrm>
+            <a:off x="6126480" y="1645920"/>
+            <a:ext cx="5257800" cy="3520440"/>
+          </a:xfrm>
+          <a:prstGeom prst="roundRect">
+            <a:avLst>
+              <a:gd name="adj" fmla="val 2338"/>
+            </a:avLst>
+          </a:prstGeom>
+          <a:solidFill>
+            <a:srgbClr val="FFFFFF"/>
+          </a:solidFill>
+          <a:ln w="12700">
+            <a:solidFill>
+              <a:srgbClr val="DBE3EA"/>
+            </a:solidFill>
+            <a:prstDash val="solid"/>
+          </a:ln>
+          <a:effectLst>
+            <a:outerShdw sx="100000" sy="100000" kx="0" ky="0" algn="bl" rotWithShape="0" blurRad="88900" dist="25400" dir="5400000">
+              <a:srgbClr val="9AA7B4">
+                <a:alpha val="35000"/>
+              </a:srgbClr>
+            </a:outerShdw>
+          </a:effectLst>
+        </p:spPr>
+      </p:sp>
+      <p:sp>
+        <p:nvSpPr>
+          <p:cNvPr id="18" name="Text 16"/>
+          <p:cNvSpPr/>
+          <p:nvPr/>
+        </p:nvSpPr>
+        <p:spPr>
+          <a:xfrm>
+            <a:off x="6492240" y="1874520"/>
+            <a:ext cx="4572000" cy="320040"/>
+          </a:xfrm>
+          <a:prstGeom prst="rect">
+            <a:avLst/>
+          </a:prstGeom>
+          <a:noFill/>
+          <a:ln/>
+        </p:spPr>
+        <p:txBody>
+          <a:bodyPr wrap="square" lIns="0" tIns="0" rIns="0" bIns="0" rtlCol="0" anchor="ctr"/>
+          <a:lstStyle/>
+          <a:p>
+            <a:pPr indent="0" marL="0">
+              <a:buNone/>
+            </a:pPr>
+            <a:r>
+              <a:rPr lang="en-US" sz="1200" b="1" spc="100" kern="0" dirty="0">
+                <a:solidFill>
+                  <a:srgbClr val="1C7293"/>
+                </a:solidFill>
+                <a:latin typeface="Calibri" pitchFamily="34" charset="0"/>
+                <a:ea typeface="Calibri" pitchFamily="34" charset="-122"/>
+                <a:cs typeface="Calibri" pitchFamily="34" charset="-120"/>
+              </a:rPr>
+              <a:t>TEST 2</a:t>
+            </a:r>
+            <a:endParaRPr lang="en-US" sz="1200" dirty="0"/>
+          </a:p>
+        </p:txBody>
+      </p:sp>
+      <p:sp>
+        <p:nvSpPr>
+          <p:cNvPr id="19" name="Text 17"/>
+          <p:cNvSpPr/>
+          <p:nvPr/>
+        </p:nvSpPr>
+        <p:spPr>
+          <a:xfrm>
+            <a:off x="6492240" y="2194560"/>
+            <a:ext cx="4572000" cy="502920"/>
+          </a:xfrm>
+          <a:prstGeom prst="rect">
+            <a:avLst/>
+          </a:prstGeom>
+          <a:noFill/>
+          <a:ln/>
+        </p:spPr>
+        <p:txBody>
+          <a:bodyPr wrap="square" lIns="0" tIns="0" rIns="0" bIns="0" rtlCol="0" anchor="ctr"/>
+          <a:lstStyle/>
+          <a:p>
+            <a:pPr indent="0" marL="0">
+              <a:buNone/>
+            </a:pPr>
+            <a:r>
+              <a:rPr lang="en-US" sz="1900" b="1" dirty="0">
+                <a:solidFill>
+                  <a:srgbClr val="1A2230"/>
+                </a:solidFill>
+                <a:latin typeface="Cambria" pitchFamily="34" charset="0"/>
+                <a:ea typeface="Cambria" pitchFamily="34" charset="-122"/>
+                <a:cs typeface="Cambria" pitchFamily="34" charset="-120"/>
+              </a:rPr>
+              <a:t>Barangay / HOA demo day</a:t>
+            </a:r>
+            <a:endParaRPr lang="en-US" sz="1900" dirty="0"/>
+          </a:p>
+        </p:txBody>
+      </p:sp>
+      <p:sp>
+        <p:nvSpPr>
+          <p:cNvPr id="20" name="Text 18"/>
+          <p:cNvSpPr/>
+          <p:nvPr/>
+        </p:nvSpPr>
+        <p:spPr>
+          <a:xfrm>
+            <a:off x="6492240" y="2788920"/>
+            <a:ext cx="1737360" cy="384048"/>
+          </a:xfrm>
+          <a:prstGeom prst="rect">
+            <a:avLst/>
+          </a:prstGeom>
+          <a:noFill/>
+          <a:ln/>
+        </p:spPr>
+        <p:txBody>
+          <a:bodyPr wrap="square" lIns="0" tIns="0" rIns="0" bIns="0" rtlCol="0" anchor="ctr"/>
+          <a:lstStyle/>
+          <a:p>
+            <a:pPr indent="0" marL="0">
+              <a:buNone/>
+            </a:pPr>
+            <a:r>
+              <a:rPr lang="en-US" sz="1250" b="1" dirty="0">
+                <a:solidFill>
+                  <a:srgbClr val="5C6B7A"/>
+                </a:solidFill>
+                <a:latin typeface="Calibri" pitchFamily="34" charset="0"/>
+                <a:ea typeface="Calibri" pitchFamily="34" charset="-122"/>
+                <a:cs typeface="Calibri" pitchFamily="34" charset="-120"/>
+              </a:rPr>
+              <a:t>Hypothesis</a:t>
+            </a:r>
+            <a:endParaRPr lang="en-US" sz="1250" dirty="0"/>
+          </a:p>
+        </p:txBody>
+      </p:sp>
+      <p:sp>
+        <p:nvSpPr>
+          <p:cNvPr id="21" name="Text 19"/>
+          <p:cNvSpPr/>
+          <p:nvPr/>
+        </p:nvSpPr>
+        <p:spPr>
+          <a:xfrm>
+            <a:off x="8183880" y="2788920"/>
+            <a:ext cx="2880360" cy="384048"/>
+          </a:xfrm>
+          <a:prstGeom prst="rect">
+            <a:avLst/>
+          </a:prstGeom>
+          <a:noFill/>
+          <a:ln/>
+        </p:spPr>
+        <p:txBody>
+          <a:bodyPr wrap="square" lIns="0" tIns="0" rIns="0" bIns="0" rtlCol="0" anchor="ctr"/>
+          <a:lstStyle/>
+          <a:p>
+            <a:pPr indent="0" marL="0">
+              <a:buNone/>
+            </a:pPr>
+            <a:r>
+              <a:rPr lang="en-US" sz="1250" dirty="0">
+                <a:solidFill>
+                  <a:srgbClr val="1A2230"/>
+                </a:solidFill>
+                <a:latin typeface="Calibri" pitchFamily="34" charset="0"/>
+                <a:ea typeface="Calibri" pitchFamily="34" charset="-122"/>
+                <a:cs typeface="Calibri" pitchFamily="34" charset="-120"/>
+              </a:rPr>
+              <a:t>touchable rig books surveys</a:t>
+            </a:r>
+            <a:endParaRPr lang="en-US" sz="1250" dirty="0"/>
+          </a:p>
+        </p:txBody>
+      </p:sp>
+      <p:sp>
+        <p:nvSpPr>
+          <p:cNvPr id="22" name="Text 20"/>
+          <p:cNvSpPr/>
+          <p:nvPr/>
+        </p:nvSpPr>
+        <p:spPr>
+          <a:xfrm>
+            <a:off x="6492240" y="3246120"/>
+            <a:ext cx="1737360" cy="384048"/>
+          </a:xfrm>
+          <a:prstGeom prst="rect">
+            <a:avLst/>
+          </a:prstGeom>
+          <a:noFill/>
+          <a:ln/>
+        </p:spPr>
+        <p:txBody>
+          <a:bodyPr wrap="square" lIns="0" tIns="0" rIns="0" bIns="0" rtlCol="0" anchor="ctr"/>
+          <a:lstStyle/>
+          <a:p>
+            <a:pPr indent="0" marL="0">
+              <a:buNone/>
+            </a:pPr>
+            <a:r>
+              <a:rPr lang="en-US" sz="1250" b="1" dirty="0">
+                <a:solidFill>
+                  <a:srgbClr val="5C6B7A"/>
+                </a:solidFill>
+                <a:latin typeface="Calibri" pitchFamily="34" charset="0"/>
+                <a:ea typeface="Calibri" pitchFamily="34" charset="-122"/>
+                <a:cs typeface="Calibri" pitchFamily="34" charset="-120"/>
+              </a:rPr>
+              <a:t>Pass bar</a:t>
+            </a:r>
+            <a:endParaRPr lang="en-US" sz="1250" dirty="0"/>
+          </a:p>
+        </p:txBody>
+      </p:sp>
+      <p:sp>
+        <p:nvSpPr>
+          <p:cNvPr id="23" name="Text 21"/>
+          <p:cNvSpPr/>
+          <p:nvPr/>
+        </p:nvSpPr>
+        <p:spPr>
+          <a:xfrm>
+            <a:off x="8183880" y="3246120"/>
+            <a:ext cx="2880360" cy="384048"/>
+          </a:xfrm>
+          <a:prstGeom prst="rect">
+            <a:avLst/>
+          </a:prstGeom>
+          <a:noFill/>
+          <a:ln/>
+        </p:spPr>
+        <p:txBody>
+          <a:bodyPr wrap="square" lIns="0" tIns="0" rIns="0" bIns="0" rtlCol="0" anchor="ctr"/>
+          <a:lstStyle/>
+          <a:p>
+            <a:pPr indent="0" marL="0">
+              <a:buNone/>
+            </a:pPr>
+            <a:r>
+              <a:rPr lang="en-US" sz="1250" dirty="0">
+                <a:solidFill>
+                  <a:srgbClr val="1A2230"/>
+                </a:solidFill>
+                <a:latin typeface="Calibri" pitchFamily="34" charset="0"/>
+                <a:ea typeface="Calibri" pitchFamily="34" charset="-122"/>
+                <a:cs typeface="Calibri" pitchFamily="34" charset="-120"/>
+              </a:rPr>
+              <a:t>≥ 5 site surveys booked</a:t>
+            </a:r>
+            <a:endParaRPr lang="en-US" sz="1250" dirty="0"/>
+          </a:p>
+        </p:txBody>
+      </p:sp>
+      <p:sp>
+        <p:nvSpPr>
+          <p:cNvPr id="24" name="Text 22"/>
+          <p:cNvSpPr/>
+          <p:nvPr/>
+        </p:nvSpPr>
+        <p:spPr>
+          <a:xfrm>
+            <a:off x="6492240" y="3703320"/>
+            <a:ext cx="1737360" cy="384048"/>
+          </a:xfrm>
+          <a:prstGeom prst="rect">
+            <a:avLst/>
+          </a:prstGeom>
+          <a:noFill/>
+          <a:ln/>
+        </p:spPr>
+        <p:txBody>
+          <a:bodyPr wrap="square" lIns="0" tIns="0" rIns="0" bIns="0" rtlCol="0" anchor="ctr"/>
+          <a:lstStyle/>
+          <a:p>
+            <a:pPr indent="0" marL="0">
+              <a:buNone/>
+            </a:pPr>
+            <a:r>
+              <a:rPr lang="en-US" sz="1250" b="1" dirty="0">
+                <a:solidFill>
+                  <a:srgbClr val="5C6B7A"/>
+                </a:solidFill>
+                <a:latin typeface="Calibri" pitchFamily="34" charset="0"/>
+                <a:ea typeface="Calibri" pitchFamily="34" charset="-122"/>
+                <a:cs typeface="Calibri" pitchFamily="34" charset="-120"/>
+              </a:rPr>
+              <a:t>Budget</a:t>
+            </a:r>
+            <a:endParaRPr lang="en-US" sz="1250" dirty="0"/>
+          </a:p>
+        </p:txBody>
+      </p:sp>
+      <p:sp>
+        <p:nvSpPr>
+          <p:cNvPr id="25" name="Text 23"/>
+          <p:cNvSpPr/>
+          <p:nvPr/>
+        </p:nvSpPr>
+        <p:spPr>
+          <a:xfrm>
+            <a:off x="8183880" y="3703320"/>
+            <a:ext cx="2880360" cy="384048"/>
+          </a:xfrm>
+          <a:prstGeom prst="rect">
+            <a:avLst/>
+          </a:prstGeom>
+          <a:noFill/>
+          <a:ln/>
+        </p:spPr>
+        <p:txBody>
+          <a:bodyPr wrap="square" lIns="0" tIns="0" rIns="0" bIns="0" rtlCol="0" anchor="ctr"/>
+          <a:lstStyle/>
+          <a:p>
+            <a:pPr indent="0" marL="0">
+              <a:buNone/>
+            </a:pPr>
+            <a:r>
+              <a:rPr lang="en-US" sz="1250" dirty="0">
+                <a:solidFill>
+                  <a:srgbClr val="1A2230"/>
+                </a:solidFill>
+                <a:latin typeface="Calibri" pitchFamily="34" charset="0"/>
+                <a:ea typeface="Calibri" pitchFamily="34" charset="-122"/>
+                <a:cs typeface="Calibri" pitchFamily="34" charset="-120"/>
+              </a:rPr>
+              <a:t>≤ ₱12k · ≤ 3 weeks</a:t>
+            </a:r>
+            <a:endParaRPr lang="en-US" sz="1250" dirty="0"/>
+          </a:p>
+        </p:txBody>
+      </p:sp>
+      <p:sp>
+        <p:nvSpPr>
+          <p:cNvPr id="26" name="Text 24"/>
+          <p:cNvSpPr/>
+          <p:nvPr/>
+        </p:nvSpPr>
+        <p:spPr>
+          <a:xfrm>
+            <a:off x="6492240" y="4160520"/>
+            <a:ext cx="1737360" cy="384048"/>
+          </a:xfrm>
+          <a:prstGeom prst="rect">
+            <a:avLst/>
+          </a:prstGeom>
+          <a:noFill/>
+          <a:ln/>
+        </p:spPr>
+        <p:txBody>
+          <a:bodyPr wrap="square" lIns="0" tIns="0" rIns="0" bIns="0" rtlCol="0" anchor="ctr"/>
+          <a:lstStyle/>
+          <a:p>
+            <a:pPr indent="0" marL="0">
+              <a:buNone/>
+            </a:pPr>
+            <a:r>
+              <a:rPr lang="en-US" sz="1250" b="1" dirty="0">
+                <a:solidFill>
+                  <a:srgbClr val="5C6B7A"/>
+                </a:solidFill>
+                <a:latin typeface="Calibri" pitchFamily="34" charset="0"/>
+                <a:ea typeface="Calibri" pitchFamily="34" charset="-122"/>
+                <a:cs typeface="Calibri" pitchFamily="34" charset="-120"/>
+              </a:rPr>
+              <a:t>Precondition</a:t>
+            </a:r>
+            <a:endParaRPr lang="en-US" sz="1250" dirty="0"/>
+          </a:p>
+        </p:txBody>
+      </p:sp>
+      <p:sp>
+        <p:nvSpPr>
+          <p:cNvPr id="27" name="Text 25"/>
+          <p:cNvSpPr/>
+          <p:nvPr/>
+        </p:nvSpPr>
+        <p:spPr>
+          <a:xfrm>
+            <a:off x="8183880" y="4160520"/>
+            <a:ext cx="2880360" cy="384048"/>
+          </a:xfrm>
+          <a:prstGeom prst="rect">
+            <a:avLst/>
+          </a:prstGeom>
+          <a:noFill/>
+          <a:ln/>
+        </p:spPr>
+        <p:txBody>
+          <a:bodyPr wrap="square" lIns="0" tIns="0" rIns="0" bIns="0" rtlCol="0" anchor="ctr"/>
+          <a:lstStyle/>
+          <a:p>
+            <a:pPr indent="0" marL="0">
+              <a:buNone/>
+            </a:pPr>
+            <a:r>
+              <a:rPr lang="en-US" sz="1250" dirty="0">
+                <a:solidFill>
+                  <a:srgbClr val="1A2230"/>
+                </a:solidFill>
+                <a:latin typeface="Calibri" pitchFamily="34" charset="0"/>
+                <a:ea typeface="Calibri" pitchFamily="34" charset="-122"/>
+                <a:cs typeface="Calibri" pitchFamily="34" charset="-120"/>
+              </a:rPr>
+              <a:t>demo rig + slice chosen</a:t>
+            </a:r>
+            <a:endParaRPr lang="en-US" sz="1250" dirty="0"/>
+          </a:p>
+        </p:txBody>
+      </p:sp>
+      <p:sp>
+        <p:nvSpPr>
+          <p:cNvPr id="28" name="Text 26"/>
+          <p:cNvSpPr/>
+          <p:nvPr/>
+        </p:nvSpPr>
+        <p:spPr>
+          <a:xfrm>
+            <a:off x="6492240" y="4617720"/>
+            <a:ext cx="1737360" cy="384048"/>
+          </a:xfrm>
+          <a:prstGeom prst="rect">
+            <a:avLst/>
+          </a:prstGeom>
+          <a:noFill/>
+          <a:ln/>
+        </p:spPr>
+        <p:txBody>
+          <a:bodyPr wrap="square" lIns="0" tIns="0" rIns="0" bIns="0" rtlCol="0" anchor="ctr"/>
+          <a:lstStyle/>
+          <a:p>
+            <a:pPr indent="0" marL="0">
+              <a:buNone/>
+            </a:pPr>
+            <a:r>
+              <a:rPr lang="en-US" sz="1250" b="1" dirty="0">
+                <a:solidFill>
+                  <a:srgbClr val="5C6B7A"/>
+                </a:solidFill>
+                <a:latin typeface="Calibri" pitchFamily="34" charset="0"/>
+                <a:ea typeface="Calibri" pitchFamily="34" charset="-122"/>
+                <a:cs typeface="Calibri" pitchFamily="34" charset="-120"/>
+              </a:rPr>
+              <a:t>Score</a:t>
+            </a:r>
+            <a:endParaRPr lang="en-US" sz="1250" dirty="0"/>
+          </a:p>
+        </p:txBody>
+      </p:sp>
+      <p:sp>
+        <p:nvSpPr>
+          <p:cNvPr id="29" name="Text 27"/>
+          <p:cNvSpPr/>
+          <p:nvPr/>
+        </p:nvSpPr>
+        <p:spPr>
+          <a:xfrm>
+            <a:off x="8183880" y="4617720"/>
+            <a:ext cx="2880360" cy="384048"/>
+          </a:xfrm>
+          <a:prstGeom prst="rect">
+            <a:avLst/>
+          </a:prstGeom>
+          <a:noFill/>
+          <a:ln/>
+        </p:spPr>
+        <p:txBody>
+          <a:bodyPr wrap="square" lIns="0" tIns="0" rIns="0" bIns="0" rtlCol="0" anchor="ctr"/>
+          <a:lstStyle/>
+          <a:p>
+            <a:pPr indent="0" marL="0">
+              <a:buNone/>
+            </a:pPr>
+            <a:r>
+              <a:rPr lang="en-US" sz="1250" dirty="0">
+                <a:solidFill>
+                  <a:srgbClr val="1A2230"/>
+                </a:solidFill>
+                <a:latin typeface="Calibri" pitchFamily="34" charset="0"/>
+                <a:ea typeface="Calibri" pitchFamily="34" charset="-122"/>
+                <a:cs typeface="Calibri" pitchFamily="34" charset="-120"/>
+              </a:rPr>
+              <a:t>pending</a:t>
+            </a:r>
+            <a:endParaRPr lang="en-US" sz="1250" dirty="0"/>
+          </a:p>
+        </p:txBody>
+      </p:sp>
+      <p:sp>
+        <p:nvSpPr>
+          <p:cNvPr id="30" name="Text 28"/>
+          <p:cNvSpPr/>
+          <p:nvPr/>
+        </p:nvSpPr>
+        <p:spPr>
+          <a:xfrm>
+            <a:off x="548640" y="5532120"/>
+            <a:ext cx="11064240" cy="822960"/>
+          </a:xfrm>
+          <a:prstGeom prst="rect">
+            <a:avLst/>
+          </a:prstGeom>
+          <a:noFill/>
+          <a:ln/>
+        </p:spPr>
+        <p:txBody>
+          <a:bodyPr wrap="square" lIns="0" tIns="0" rIns="0" bIns="0" rtlCol="0" anchor="ctr"/>
+          <a:lstStyle/>
+          <a:p>
+            <a:pPr indent="0" marL="0">
+              <a:lnSpc>
+                <a:spcPct val="110000"/>
+              </a:lnSpc>
+              <a:buNone/>
+            </a:pPr>
+            <a:r>
+              <a:rPr lang="en-US" sz="1300" i="1" dirty="0">
+                <a:solidFill>
+                  <a:srgbClr val="1C7293"/>
+                </a:solidFill>
+                <a:latin typeface="Calibri" pitchFamily="34" charset="0"/>
+                <a:ea typeface="Calibri" pitchFamily="34" charset="-122"/>
+                <a:cs typeface="Calibri" pitchFamily="34" charset="-120"/>
+              </a:rPr>
+              <a:t>Rules: max 3 concurrent tests · no ad peso until the funnel delivers end-to-end · an unscored test blocks the next · don't scale until ≥2 real deposits.</a:t>
+            </a:r>
+            <a:endParaRPr lang="en-US" sz="1300" dirty="0"/>
+          </a:p>
+        </p:txBody>
+      </p:sp>
+    </p:spTree>
+  </p:cSld>
+  <p:clrMapOvr>
+    <a:masterClrMapping/>
+  </p:clrMapOvr>
+</p:sld>
+</file>
+
+<file path=ppt/slides/slide17.xml><?xml version="1.0" encoding="utf-8"?>
+<p:sld xmlns:a="http://schemas.openxmlformats.org/drawingml/2006/main" xmlns:r="http://schemas.openxmlformats.org/officeDocument/2006/relationships" xmlns:p="http://schemas.openxmlformats.org/presentationml/2006/main">
+  <p:cSld name="Slide 17">
+    <p:bg>
+      <p:bgPr>
+        <a:solidFill>
           <a:srgbClr val="12233A"/>
         </a:solidFill>
       </p:bgPr>

</xml_diff>